<commit_message>
Timeline: show full phase names on cards and legend
Co-Authored-By: Claude Sonnet 5.5 <noreply@anthropic.com>
Claude-Session: https://claude.ai/code/session_015CooLRRU7X55XCWBXAPEMd
</commit_message>
<xml_diff>
--- a/ufwl-timeline/UFWL_Timeline_AR_sample.pptx
+++ b/ufwl-timeline/UFWL_Timeline_AR_sample.pptx
@@ -1257,8 +1257,8 @@
         </p:nvSpPr>
         <p:spPr>
           <a:xfrm>
-            <a:off x="10623499" y="1005840"/>
-            <a:ext cx="891540" cy="237744"/>
+            <a:off x="10126980" y="1005840"/>
+            <a:ext cx="1388059" cy="237744"/>
           </a:xfrm>
           <a:prstGeom prst="rect">
             <a:avLst/>
@@ -1276,7 +1276,7 @@
               <a:buNone/>
             </a:pPr>
             <a:r>
-              <a:rPr lang="ar-SA" altLang="en-US" sz="950" dirty="0">
+              <a:rPr lang="ar-SA" altLang="en-US" sz="900" b="1" dirty="0">
                 <a:solidFill>
                   <a:srgbClr val="333333"/>
                 </a:solidFill>
@@ -1284,9 +1284,9 @@
                 <a:ea typeface="Arial" pitchFamily="34" charset="-122"/>
                 <a:cs typeface="Arial" pitchFamily="34" charset="-120"/>
               </a:rPr>
-              <a:t>الخلفية</a:t>
-            </a:r>
-            <a:endParaRPr lang="ar-SA" sz="950" dirty="0"/>
+              <a:t>الخلفية – طلب التصريح</a:t>
+            </a:r>
+            <a:endParaRPr lang="ar-SA" sz="900" dirty="0"/>
           </a:p>
         </p:txBody>
       </p:sp>
@@ -1298,7 +1298,7 @@
         </p:nvSpPr>
         <p:spPr>
           <a:xfrm>
-            <a:off x="10358323" y="1069848"/>
+            <a:off x="9816084" y="1069848"/>
             <a:ext cx="256032" cy="109728"/>
           </a:xfrm>
           <a:prstGeom prst="roundRect">
@@ -1325,8 +1325,8 @@
         </p:nvSpPr>
         <p:spPr>
           <a:xfrm>
-            <a:off x="9274759" y="1005840"/>
-            <a:ext cx="1028700" cy="237744"/>
+            <a:off x="7736738" y="1005840"/>
+            <a:ext cx="2024482" cy="237744"/>
           </a:xfrm>
           <a:prstGeom prst="rect">
             <a:avLst/>
@@ -1344,7 +1344,7 @@
               <a:buNone/>
             </a:pPr>
             <a:r>
-              <a:rPr lang="ar-SA" altLang="en-US" sz="950" dirty="0">
+              <a:rPr lang="ar-SA" altLang="en-US" sz="900" b="1" dirty="0">
                 <a:solidFill>
                   <a:srgbClr val="333333"/>
                 </a:solidFill>
@@ -1352,9 +1352,9 @@
                 <a:ea typeface="Arial" pitchFamily="34" charset="-122"/>
                 <a:cs typeface="Arial" pitchFamily="34" charset="-120"/>
               </a:rPr>
-              <a:t>المرحلة 1</a:t>
-            </a:r>
-            <a:endParaRPr lang="ar-SA" sz="950" dirty="0"/>
+              <a:t>المرحلة 1 – الإيقاف وتقييم الموقع</a:t>
+            </a:r>
+            <a:endParaRPr lang="ar-SA" sz="900" dirty="0"/>
           </a:p>
         </p:txBody>
       </p:sp>
@@ -1366,7 +1366,7 @@
         </p:nvSpPr>
         <p:spPr>
           <a:xfrm>
-            <a:off x="9009583" y="1069848"/>
+            <a:off x="7425842" y="1069848"/>
             <a:ext cx="256032" cy="109728"/>
           </a:xfrm>
           <a:prstGeom prst="roundRect">
@@ -1393,8 +1393,8 @@
         </p:nvSpPr>
         <p:spPr>
           <a:xfrm>
-            <a:off x="7926019" y="1005840"/>
-            <a:ext cx="1028700" cy="237744"/>
+            <a:off x="4869180" y="1005840"/>
+            <a:ext cx="2501798" cy="237744"/>
           </a:xfrm>
           <a:prstGeom prst="rect">
             <a:avLst/>
@@ -1412,7 +1412,7 @@
               <a:buNone/>
             </a:pPr>
             <a:r>
-              <a:rPr lang="ar-SA" altLang="en-US" sz="950" dirty="0">
+              <a:rPr lang="ar-SA" altLang="en-US" sz="900" b="1" dirty="0">
                 <a:solidFill>
                   <a:srgbClr val="333333"/>
                 </a:solidFill>
@@ -1420,9 +1420,9 @@
                 <a:ea typeface="Arial" pitchFamily="34" charset="-122"/>
                 <a:cs typeface="Arial" pitchFamily="34" charset="-120"/>
               </a:rPr>
-              <a:t>المرحلة 2</a:t>
-            </a:r>
-            <a:endParaRPr lang="ar-SA" sz="950" dirty="0"/>
+              <a:t>المرحلة 2 – إعداد ومراجعة بيان طريقة العمل</a:t>
+            </a:r>
+            <a:endParaRPr lang="ar-SA" sz="900" dirty="0"/>
           </a:p>
         </p:txBody>
       </p:sp>
@@ -1434,7 +1434,7 @@
         </p:nvSpPr>
         <p:spPr>
           <a:xfrm>
-            <a:off x="7660843" y="1069848"/>
+            <a:off x="4558284" y="1069848"/>
             <a:ext cx="256032" cy="109728"/>
           </a:xfrm>
           <a:prstGeom prst="roundRect">
@@ -1461,8 +1461,8 @@
         </p:nvSpPr>
         <p:spPr>
           <a:xfrm>
-            <a:off x="6577279" y="1005840"/>
-            <a:ext cx="1028700" cy="237744"/>
+            <a:off x="2691079" y="1005840"/>
+            <a:ext cx="1812341" cy="237744"/>
           </a:xfrm>
           <a:prstGeom prst="rect">
             <a:avLst/>
@@ -1480,7 +1480,7 @@
               <a:buNone/>
             </a:pPr>
             <a:r>
-              <a:rPr lang="ar-SA" altLang="en-US" sz="950" dirty="0">
+              <a:rPr lang="ar-SA" altLang="en-US" sz="900" b="1" dirty="0">
                 <a:solidFill>
                   <a:srgbClr val="333333"/>
                 </a:solidFill>
@@ -1488,9 +1488,9 @@
                 <a:ea typeface="Arial" pitchFamily="34" charset="-122"/>
                 <a:cs typeface="Arial" pitchFamily="34" charset="-120"/>
               </a:rPr>
-              <a:t>المرحلة 3</a:t>
-            </a:r>
-            <a:endParaRPr lang="ar-SA" sz="950" dirty="0"/>
+              <a:t>المرحلة 3 – إصدار تصريح العمل</a:t>
+            </a:r>
+            <a:endParaRPr lang="ar-SA" sz="900" dirty="0"/>
           </a:p>
         </p:txBody>
       </p:sp>
@@ -2167,7 +2167,7 @@
               <a:buNone/>
             </a:pPr>
             <a:r>
-              <a:rPr lang="ar-SA" altLang="en-US" sz="650" b="1" dirty="0">
+              <a:rPr lang="ar-SA" altLang="en-US" sz="750" b="1" dirty="0">
                 <a:solidFill>
                   <a:srgbClr val="7A8791"/>
                 </a:solidFill>
@@ -2175,9 +2175,9 @@
                 <a:ea typeface="Arial" pitchFamily="34" charset="-122"/>
                 <a:cs typeface="Arial" pitchFamily="34" charset="-120"/>
               </a:rPr>
-              <a:t>1.1 · الخلفية</a:t>
-            </a:r>
-            <a:endParaRPr lang="ar-SA" sz="650" dirty="0"/>
+              <a:t>الخلفية – طلب التصريح</a:t>
+            </a:r>
+            <a:endParaRPr lang="ar-SA" sz="750" dirty="0"/>
           </a:p>
           <a:p>
             <a:pPr algn="r" indent="0" marL="0">
@@ -2197,7 +2197,7 @@
               </a:rPr>
               <a:t>طلب تصريح العمل</a:t>
             </a:r>
-            <a:endParaRPr lang="ar-SA" sz="650" dirty="0"/>
+            <a:endParaRPr lang="ar-SA" sz="750" dirty="0"/>
           </a:p>
           <a:p>
             <a:pPr algn="r" indent="0" marL="0">
@@ -2217,7 +2217,7 @@
               </a:rPr>
               <a:t>اثنين 31 أغسطس</a:t>
             </a:r>
-            <a:endParaRPr lang="ar-SA" sz="650" dirty="0"/>
+            <a:endParaRPr lang="ar-SA" sz="750" dirty="0"/>
           </a:p>
           <a:p>
             <a:pPr algn="r" indent="0" marL="0">
@@ -2237,7 +2237,7 @@
               </a:rPr>
               <a:t>طلب تصريح لتنفيذ أعمال الأساسات لإزالة خطر انهيار التربة.</a:t>
             </a:r>
-            <a:endParaRPr lang="ar-SA" sz="650" dirty="0"/>
+            <a:endParaRPr lang="ar-SA" sz="750" dirty="0"/>
           </a:p>
         </p:txBody>
       </p:sp>
@@ -2428,7 +2428,7 @@
               <a:buNone/>
             </a:pPr>
             <a:r>
-              <a:rPr lang="ar-SA" altLang="en-US" sz="650" b="1" dirty="0">
+              <a:rPr lang="ar-SA" altLang="en-US" sz="750" b="1" dirty="0">
                 <a:solidFill>
                   <a:srgbClr val="7A8791"/>
                 </a:solidFill>
@@ -2436,9 +2436,9 @@
                 <a:ea typeface="Arial" pitchFamily="34" charset="-122"/>
                 <a:cs typeface="Arial" pitchFamily="34" charset="-120"/>
               </a:rPr>
-              <a:t>1.2 · الخلفية</a:t>
-            </a:r>
-            <a:endParaRPr lang="ar-SA" sz="650" dirty="0"/>
+              <a:t>الخلفية – طلب التصريح</a:t>
+            </a:r>
+            <a:endParaRPr lang="ar-SA" sz="750" dirty="0"/>
           </a:p>
           <a:p>
             <a:pPr algn="r" indent="0" marL="0">
@@ -2458,7 +2458,7 @@
               </a:rPr>
               <a:t>رفض طلب التصريح</a:t>
             </a:r>
-            <a:endParaRPr lang="ar-SA" sz="650" dirty="0"/>
+            <a:endParaRPr lang="ar-SA" sz="750" dirty="0"/>
           </a:p>
           <a:p>
             <a:pPr algn="r" indent="0" marL="0">
@@ -2478,7 +2478,7 @@
               </a:rPr>
               <a:t>اثنين 28 سبتمبر</a:t>
             </a:r>
-            <a:endParaRPr lang="ar-SA" sz="650" dirty="0"/>
+            <a:endParaRPr lang="ar-SA" sz="750" dirty="0"/>
           </a:p>
           <a:p>
             <a:pPr algn="r" indent="0" marL="0">
@@ -2498,7 +2498,7 @@
               </a:rPr>
               <a:t>رفضت إدارة التصاريح طلب تصريح العمل.</a:t>
             </a:r>
-            <a:endParaRPr lang="ar-SA" sz="650" dirty="0"/>
+            <a:endParaRPr lang="ar-SA" sz="750" dirty="0"/>
           </a:p>
         </p:txBody>
       </p:sp>
@@ -2689,7 +2689,7 @@
               <a:buNone/>
             </a:pPr>
             <a:r>
-              <a:rPr lang="ar-SA" altLang="en-US" sz="650" b="1" dirty="0">
+              <a:rPr lang="ar-SA" altLang="en-US" sz="750" b="1" dirty="0">
                 <a:solidFill>
                   <a:srgbClr val="C8503F"/>
                 </a:solidFill>
@@ -2697,9 +2697,9 @@
                 <a:ea typeface="Arial" pitchFamily="34" charset="-122"/>
                 <a:cs typeface="Arial" pitchFamily="34" charset="-120"/>
               </a:rPr>
-              <a:t>2.1 · المرحلة 1</a:t>
-            </a:r>
-            <a:endParaRPr lang="ar-SA" sz="650" dirty="0"/>
+              <a:t>المرحلة 1 – الإيقاف وتقييم الموقع</a:t>
+            </a:r>
+            <a:endParaRPr lang="ar-SA" sz="750" dirty="0"/>
           </a:p>
           <a:p>
             <a:pPr algn="r" indent="0" marL="0">
@@ -2719,7 +2719,7 @@
               </a:rPr>
               <a:t>إيقاف أنشطة المشروع</a:t>
             </a:r>
-            <a:endParaRPr lang="ar-SA" sz="650" dirty="0"/>
+            <a:endParaRPr lang="ar-SA" sz="750" dirty="0"/>
           </a:p>
           <a:p>
             <a:pPr algn="r" indent="0" marL="0">
@@ -2739,7 +2739,7 @@
               </a:rPr>
               <a:t>خميس 1 أكتوبر</a:t>
             </a:r>
-            <a:endParaRPr lang="ar-SA" sz="650" dirty="0"/>
+            <a:endParaRPr lang="ar-SA" sz="750" dirty="0"/>
           </a:p>
           <a:p>
             <a:pPr algn="r" indent="0" marL="0">
@@ -2759,7 +2759,7 @@
               </a:rPr>
               <a:t>أوقفت إدارة التصاريح والسلامة جميع أنشطة المشروع بالموقع.</a:t>
             </a:r>
-            <a:endParaRPr lang="ar-SA" sz="650" dirty="0"/>
+            <a:endParaRPr lang="ar-SA" sz="750" dirty="0"/>
           </a:p>
         </p:txBody>
       </p:sp>
@@ -2950,7 +2950,7 @@
               <a:buNone/>
             </a:pPr>
             <a:r>
-              <a:rPr lang="ar-SA" altLang="en-US" sz="650" b="1" dirty="0">
+              <a:rPr lang="ar-SA" altLang="en-US" sz="750" b="1" dirty="0">
                 <a:solidFill>
                   <a:srgbClr val="C8503F"/>
                 </a:solidFill>
@@ -2958,9 +2958,9 @@
                 <a:ea typeface="Arial" pitchFamily="34" charset="-122"/>
                 <a:cs typeface="Arial" pitchFamily="34" charset="-120"/>
               </a:rPr>
-              <a:t>2.2 · المرحلة 1</a:t>
-            </a:r>
-            <a:endParaRPr lang="ar-SA" sz="650" dirty="0"/>
+              <a:t>المرحلة 1 – الإيقاف وتقييم الموقع</a:t>
+            </a:r>
+            <a:endParaRPr lang="ar-SA" sz="750" dirty="0"/>
           </a:p>
           <a:p>
             <a:pPr algn="r" indent="0" marL="0">
@@ -2980,7 +2980,7 @@
               </a:rPr>
               <a:t>زيارة ميدانية مشتركة</a:t>
             </a:r>
-            <a:endParaRPr lang="ar-SA" sz="650" dirty="0"/>
+            <a:endParaRPr lang="ar-SA" sz="750" dirty="0"/>
           </a:p>
           <a:p>
             <a:pPr algn="r" indent="0" marL="0">
@@ -3000,7 +3000,7 @@
               </a:rPr>
               <a:t>سبت 3 أكتوبر</a:t>
             </a:r>
-            <a:endParaRPr lang="ar-SA" sz="650" dirty="0"/>
+            <a:endParaRPr lang="ar-SA" sz="750" dirty="0"/>
           </a:p>
           <a:p>
             <a:pPr algn="r" indent="0" marL="0">
@@ -3020,7 +3020,7 @@
               </a:rPr>
               <a:t>زيارة مشتركة مع الإدارات المعنية (التصاريح وغيرها) لتقييم حالة الموقع.</a:t>
             </a:r>
-            <a:endParaRPr lang="ar-SA" sz="650" dirty="0"/>
+            <a:endParaRPr lang="ar-SA" sz="750" dirty="0"/>
           </a:p>
         </p:txBody>
       </p:sp>
@@ -3211,7 +3211,7 @@
               <a:buNone/>
             </a:pPr>
             <a:r>
-              <a:rPr lang="ar-SA" altLang="en-US" sz="650" b="1" dirty="0">
+              <a:rPr lang="ar-SA" altLang="en-US" sz="750" b="1" dirty="0">
                 <a:solidFill>
                   <a:srgbClr val="C8503F"/>
                 </a:solidFill>
@@ -3219,9 +3219,9 @@
                 <a:ea typeface="Arial" pitchFamily="34" charset="-122"/>
                 <a:cs typeface="Arial" pitchFamily="34" charset="-120"/>
               </a:rPr>
-              <a:t>2.3 · المرحلة 1</a:t>
-            </a:r>
-            <a:endParaRPr lang="ar-SA" sz="650" dirty="0"/>
+              <a:t>المرحلة 1 – الإيقاف وتقييم الموقع</a:t>
+            </a:r>
+            <a:endParaRPr lang="ar-SA" sz="750" dirty="0"/>
           </a:p>
           <a:p>
             <a:pPr algn="r" indent="0" marL="0">
@@ -3241,7 +3241,7 @@
               </a:rPr>
               <a:t>تقديم تقييم المخاطر وخطة التخفيف</a:t>
             </a:r>
-            <a:endParaRPr lang="ar-SA" sz="650" dirty="0"/>
+            <a:endParaRPr lang="ar-SA" sz="750" dirty="0"/>
           </a:p>
           <a:p>
             <a:pPr algn="r" indent="0" marL="0">
@@ -3261,7 +3261,7 @@
               </a:rPr>
               <a:t>أحد 4 أكتوبر</a:t>
             </a:r>
-            <a:endParaRPr lang="ar-SA" sz="650" dirty="0"/>
+            <a:endParaRPr lang="ar-SA" sz="750" dirty="0"/>
           </a:p>
           <a:p>
             <a:pPr algn="r" indent="0" marL="0">
@@ -3281,7 +3281,7 @@
               </a:rPr>
               <a:t>أُرسلت إلى إدارة التصاريح بهدف استئناف العمل.</a:t>
             </a:r>
-            <a:endParaRPr lang="ar-SA" sz="650" dirty="0"/>
+            <a:endParaRPr lang="ar-SA" sz="750" dirty="0"/>
           </a:p>
         </p:txBody>
       </p:sp>
@@ -3472,7 +3472,7 @@
               <a:buNone/>
             </a:pPr>
             <a:r>
-              <a:rPr lang="ar-SA" altLang="en-US" sz="650" b="1" dirty="0">
+              <a:rPr lang="ar-SA" altLang="en-US" sz="750" b="1" dirty="0">
                 <a:solidFill>
                   <a:srgbClr val="C8503F"/>
                 </a:solidFill>
@@ -3480,9 +3480,9 @@
                 <a:ea typeface="Arial" pitchFamily="34" charset="-122"/>
                 <a:cs typeface="Arial" pitchFamily="34" charset="-120"/>
               </a:rPr>
-              <a:t>2.4 · المرحلة 1</a:t>
-            </a:r>
-            <a:endParaRPr lang="ar-SA" sz="650" dirty="0"/>
+              <a:t>المرحلة 1 – الإيقاف وتقييم الموقع</a:t>
+            </a:r>
+            <a:endParaRPr lang="ar-SA" sz="750" dirty="0"/>
           </a:p>
           <a:p>
             <a:pPr algn="r" indent="0" marL="0">
@@ -3502,7 +3502,7 @@
               </a:rPr>
               <a:t>طلب خطة عمل تفصيلية</a:t>
             </a:r>
-            <a:endParaRPr lang="ar-SA" sz="650" dirty="0"/>
+            <a:endParaRPr lang="ar-SA" sz="750" dirty="0"/>
           </a:p>
           <a:p>
             <a:pPr algn="r" indent="0" marL="0">
@@ -3522,7 +3522,7 @@
               </a:rPr>
               <a:t>اثنين 5 أكتوبر</a:t>
             </a:r>
-            <a:endParaRPr lang="ar-SA" sz="650" dirty="0"/>
+            <a:endParaRPr lang="ar-SA" sz="750" dirty="0"/>
           </a:p>
           <a:p>
             <a:pPr algn="r" indent="0" marL="0">
@@ -3542,7 +3542,7 @@
               </a:rPr>
               <a:t>طلبت إدارة التصاريح خطة عمل أكثر تفصيلاً.</a:t>
             </a:r>
-            <a:endParaRPr lang="ar-SA" sz="650" dirty="0"/>
+            <a:endParaRPr lang="ar-SA" sz="750" dirty="0"/>
           </a:p>
         </p:txBody>
       </p:sp>
@@ -3733,7 +3733,7 @@
               <a:buNone/>
             </a:pPr>
             <a:r>
-              <a:rPr lang="ar-SA" altLang="en-US" sz="650" b="1" dirty="0">
+              <a:rPr lang="ar-SA" altLang="en-US" sz="750" b="1" dirty="0">
                 <a:solidFill>
                   <a:srgbClr val="00778B"/>
                 </a:solidFill>
@@ -3741,9 +3741,9 @@
                 <a:ea typeface="Arial" pitchFamily="34" charset="-122"/>
                 <a:cs typeface="Arial" pitchFamily="34" charset="-120"/>
               </a:rPr>
-              <a:t>3.1 · المرحلة 2</a:t>
-            </a:r>
-            <a:endParaRPr lang="ar-SA" sz="650" dirty="0"/>
+              <a:t>المرحلة 2 – إعداد ومراجعة بيان طريقة العمل</a:t>
+            </a:r>
+            <a:endParaRPr lang="ar-SA" sz="750" dirty="0"/>
           </a:p>
           <a:p>
             <a:pPr algn="r" indent="0" marL="0">
@@ -3763,7 +3763,7 @@
               </a:rPr>
               <a:t>تقديم بيان طريقة العمل (MoS)</a:t>
             </a:r>
-            <a:endParaRPr lang="ar-SA" sz="650" dirty="0"/>
+            <a:endParaRPr lang="ar-SA" sz="750" dirty="0"/>
           </a:p>
           <a:p>
             <a:pPr algn="r" indent="0" marL="0">
@@ -3783,7 +3783,7 @@
               </a:rPr>
               <a:t>أربعاء 7 أكتوبر</a:t>
             </a:r>
-            <a:endParaRPr lang="ar-SA" sz="650" dirty="0"/>
+            <a:endParaRPr lang="ar-SA" sz="750" dirty="0"/>
           </a:p>
           <a:p>
             <a:pPr algn="r" indent="0" marL="0">
@@ -3803,7 +3803,7 @@
               </a:rPr>
               <a:t>بيان طريقة العمل وخطة العمل التفصيلية لجميع الإدارات للمراجعة والاعتماد.</a:t>
             </a:r>
-            <a:endParaRPr lang="ar-SA" sz="650" dirty="0"/>
+            <a:endParaRPr lang="ar-SA" sz="750" dirty="0"/>
           </a:p>
         </p:txBody>
       </p:sp>
@@ -3994,7 +3994,7 @@
               <a:buNone/>
             </a:pPr>
             <a:r>
-              <a:rPr lang="ar-SA" altLang="en-US" sz="650" b="1" dirty="0">
+              <a:rPr lang="ar-SA" altLang="en-US" sz="750" b="1" dirty="0">
                 <a:solidFill>
                   <a:srgbClr val="00778B"/>
                 </a:solidFill>
@@ -4002,9 +4002,9 @@
                 <a:ea typeface="Arial" pitchFamily="34" charset="-122"/>
                 <a:cs typeface="Arial" pitchFamily="34" charset="-120"/>
               </a:rPr>
-              <a:t>3.2 · المرحلة 2</a:t>
-            </a:r>
-            <a:endParaRPr lang="ar-SA" sz="650" dirty="0"/>
+              <a:t>المرحلة 2 – إعداد ومراجعة بيان طريقة العمل</a:t>
+            </a:r>
+            <a:endParaRPr lang="ar-SA" sz="750" dirty="0"/>
           </a:p>
           <a:p>
             <a:pPr algn="r" indent="0" marL="0">
@@ -4024,7 +4024,7 @@
               </a:rPr>
               <a:t>اجتماع أصحاب المصلحة</a:t>
             </a:r>
-            <a:endParaRPr lang="ar-SA" sz="650" dirty="0"/>
+            <a:endParaRPr lang="ar-SA" sz="750" dirty="0"/>
           </a:p>
           <a:p>
             <a:pPr algn="r" indent="0" marL="0">
@@ -4044,7 +4044,7 @@
               </a:rPr>
               <a:t>أربعاء 7 أكتوبر</a:t>
             </a:r>
-            <a:endParaRPr lang="ar-SA" sz="650" dirty="0"/>
+            <a:endParaRPr lang="ar-SA" sz="750" dirty="0"/>
           </a:p>
           <a:p>
             <a:pPr algn="r" indent="0" marL="0">
@@ -4064,7 +4064,7 @@
               </a:rPr>
               <a:t>الاتفاق على المضي قدماً وطلب مراجعة الإجراءات واعتمادها من الإدارات.</a:t>
             </a:r>
-            <a:endParaRPr lang="ar-SA" sz="650" dirty="0"/>
+            <a:endParaRPr lang="ar-SA" sz="750" dirty="0"/>
           </a:p>
         </p:txBody>
       </p:sp>
@@ -4255,7 +4255,7 @@
               <a:buNone/>
             </a:pPr>
             <a:r>
-              <a:rPr lang="ar-SA" altLang="en-US" sz="650" b="1" dirty="0">
+              <a:rPr lang="ar-SA" altLang="en-US" sz="750" b="1" dirty="0">
                 <a:solidFill>
                   <a:srgbClr val="00778B"/>
                 </a:solidFill>
@@ -4263,9 +4263,9 @@
                 <a:ea typeface="Arial" pitchFamily="34" charset="-122"/>
                 <a:cs typeface="Arial" pitchFamily="34" charset="-120"/>
               </a:rPr>
-              <a:t>3.3 · المرحلة 2</a:t>
-            </a:r>
-            <a:endParaRPr lang="ar-SA" sz="650" dirty="0"/>
+              <a:t>المرحلة 2 – إعداد ومراجعة بيان طريقة العمل</a:t>
+            </a:r>
+            <a:endParaRPr lang="ar-SA" sz="750" dirty="0"/>
           </a:p>
           <a:p>
             <a:pPr algn="r" indent="0" marL="0">
@@ -4285,7 +4285,7 @@
               </a:rPr>
               <a:t>الرد على استفسارات أصحاب المصلحة</a:t>
             </a:r>
-            <a:endParaRPr lang="ar-SA" sz="650" dirty="0"/>
+            <a:endParaRPr lang="ar-SA" sz="750" dirty="0"/>
           </a:p>
           <a:p>
             <a:pPr algn="r" indent="0" marL="0">
@@ -4305,7 +4305,7 @@
               </a:rPr>
               <a:t>خميس 8 أكتوبر</a:t>
             </a:r>
-            <a:endParaRPr lang="ar-SA" sz="650" dirty="0"/>
+            <a:endParaRPr lang="ar-SA" sz="750" dirty="0"/>
           </a:p>
           <a:p>
             <a:pPr algn="r" indent="0" marL="0">
@@ -4325,7 +4325,7 @@
               </a:rPr>
               <a:t>تم الرد على كل الاستفسارات بشأن الأعمال وإجراءات السلامة.</a:t>
             </a:r>
-            <a:endParaRPr lang="ar-SA" sz="650" dirty="0"/>
+            <a:endParaRPr lang="ar-SA" sz="750" dirty="0"/>
           </a:p>
         </p:txBody>
       </p:sp>
@@ -4516,7 +4516,7 @@
               <a:buNone/>
             </a:pPr>
             <a:r>
-              <a:rPr lang="ar-SA" altLang="en-US" sz="650" b="1" dirty="0">
+              <a:rPr lang="ar-SA" altLang="en-US" sz="750" b="1" dirty="0">
                 <a:solidFill>
                   <a:srgbClr val="00778B"/>
                 </a:solidFill>
@@ -4524,9 +4524,9 @@
                 <a:ea typeface="Arial" pitchFamily="34" charset="-122"/>
                 <a:cs typeface="Arial" pitchFamily="34" charset="-120"/>
               </a:rPr>
-              <a:t>3.4 · المرحلة 2</a:t>
-            </a:r>
-            <a:endParaRPr lang="ar-SA" sz="650" dirty="0"/>
+              <a:t>المرحلة 2 – إعداد ومراجعة بيان طريقة العمل</a:t>
+            </a:r>
+            <a:endParaRPr lang="ar-SA" sz="750" dirty="0"/>
           </a:p>
           <a:p>
             <a:pPr algn="r" indent="0" marL="0">
@@ -4546,7 +4546,7 @@
               </a:rPr>
               <a:t>استلام توضيح من إدارة الهندسة</a:t>
             </a:r>
-            <a:endParaRPr lang="ar-SA" sz="650" dirty="0"/>
+            <a:endParaRPr lang="ar-SA" sz="750" dirty="0"/>
           </a:p>
           <a:p>
             <a:pPr algn="r" indent="0" marL="0">
@@ -4566,7 +4566,7 @@
               </a:rPr>
               <a:t>أحد 11 أكتوبر</a:t>
             </a:r>
-            <a:endParaRPr lang="ar-SA" sz="650" dirty="0"/>
+            <a:endParaRPr lang="ar-SA" sz="750" dirty="0"/>
           </a:p>
           <a:p>
             <a:pPr algn="r" indent="0" marL="0">
@@ -4586,7 +4586,7 @@
               </a:rPr>
               <a:t>أثارت إدارة الهندسة استيضاحاً على بيان طريقة العمل.</a:t>
             </a:r>
-            <a:endParaRPr lang="ar-SA" sz="650" dirty="0"/>
+            <a:endParaRPr lang="ar-SA" sz="750" dirty="0"/>
           </a:p>
         </p:txBody>
       </p:sp>
@@ -4777,7 +4777,7 @@
               <a:buNone/>
             </a:pPr>
             <a:r>
-              <a:rPr lang="ar-SA" altLang="en-US" sz="650" b="1" dirty="0">
+              <a:rPr lang="ar-SA" altLang="en-US" sz="750" b="1" dirty="0">
                 <a:solidFill>
                   <a:srgbClr val="00778B"/>
                 </a:solidFill>
@@ -4785,9 +4785,9 @@
                 <a:ea typeface="Arial" pitchFamily="34" charset="-122"/>
                 <a:cs typeface="Arial" pitchFamily="34" charset="-120"/>
               </a:rPr>
-              <a:t>3.5 · المرحلة 2</a:t>
-            </a:r>
-            <a:endParaRPr lang="ar-SA" sz="650" dirty="0"/>
+              <a:t>المرحلة 2 – إعداد ومراجعة بيان طريقة العمل</a:t>
+            </a:r>
+            <a:endParaRPr lang="ar-SA" sz="750" dirty="0"/>
           </a:p>
           <a:p>
             <a:pPr algn="r" indent="0" marL="0">
@@ -4807,7 +4807,7 @@
               </a:rPr>
               <a:t>تقديم المراجعة الثانية (MoS)</a:t>
             </a:r>
-            <a:endParaRPr lang="ar-SA" sz="650" dirty="0"/>
+            <a:endParaRPr lang="ar-SA" sz="750" dirty="0"/>
           </a:p>
           <a:p>
             <a:pPr algn="r" indent="0" marL="0">
@@ -4827,7 +4827,7 @@
               </a:rPr>
               <a:t>اثنين 12 أكتوبر</a:t>
             </a:r>
-            <a:endParaRPr lang="ar-SA" sz="650" dirty="0"/>
+            <a:endParaRPr lang="ar-SA" sz="750" dirty="0"/>
           </a:p>
           <a:p>
             <a:pPr algn="r" indent="0" marL="0">
@@ -4847,7 +4847,7 @@
               </a:rPr>
               <a:t>قُدّمت المراجعة الثانية للبيان إلى جميع الإدارات المعنية.</a:t>
             </a:r>
-            <a:endParaRPr lang="ar-SA" sz="650" dirty="0"/>
+            <a:endParaRPr lang="ar-SA" sz="750" dirty="0"/>
           </a:p>
         </p:txBody>
       </p:sp>
@@ -5038,7 +5038,7 @@
               <a:buNone/>
             </a:pPr>
             <a:r>
-              <a:rPr lang="ar-SA" altLang="en-US" sz="650" b="1" dirty="0">
+              <a:rPr lang="ar-SA" altLang="en-US" sz="750" b="1" dirty="0">
                 <a:solidFill>
                   <a:srgbClr val="2E9E6B"/>
                 </a:solidFill>
@@ -5046,9 +5046,9 @@
                 <a:ea typeface="Arial" pitchFamily="34" charset="-122"/>
                 <a:cs typeface="Arial" pitchFamily="34" charset="-120"/>
               </a:rPr>
-              <a:t>4.1 · المرحلة 3</a:t>
-            </a:r>
-            <a:endParaRPr lang="ar-SA" sz="650" dirty="0"/>
+              <a:t>المرحلة 3 – إصدار تصريح العمل</a:t>
+            </a:r>
+            <a:endParaRPr lang="ar-SA" sz="750" dirty="0"/>
           </a:p>
           <a:p>
             <a:pPr algn="r" indent="0" marL="0">
@@ -5068,7 +5068,7 @@
               </a:rPr>
               <a:t>التواصل مع إدارة السلامة</a:t>
             </a:r>
-            <a:endParaRPr lang="ar-SA" sz="650" dirty="0"/>
+            <a:endParaRPr lang="ar-SA" sz="750" dirty="0"/>
           </a:p>
           <a:p>
             <a:pPr algn="r" indent="0" marL="0">
@@ -5088,7 +5088,7 @@
               </a:rPr>
               <a:t>ثلاثاء 13 أكتوبر</a:t>
             </a:r>
-            <a:endParaRPr lang="ar-SA" sz="650" dirty="0"/>
+            <a:endParaRPr lang="ar-SA" sz="750" dirty="0"/>
           </a:p>
           <a:p>
             <a:pPr algn="r" indent="0" marL="0">
@@ -5108,7 +5108,7 @@
               </a:rPr>
               <a:t>بعد مشاركة المستندات تم التواصل مع السلامة لتسهيل إصدار التصريح.</a:t>
             </a:r>
-            <a:endParaRPr lang="ar-SA" sz="650" dirty="0"/>
+            <a:endParaRPr lang="ar-SA" sz="750" dirty="0"/>
           </a:p>
         </p:txBody>
       </p:sp>
@@ -5299,7 +5299,7 @@
               <a:buNone/>
             </a:pPr>
             <a:r>
-              <a:rPr lang="ar-SA" altLang="en-US" sz="650" b="1" dirty="0">
+              <a:rPr lang="ar-SA" altLang="en-US" sz="750" b="1" dirty="0">
                 <a:solidFill>
                   <a:srgbClr val="2E9E6B"/>
                 </a:solidFill>
@@ -5307,9 +5307,9 @@
                 <a:ea typeface="Arial" pitchFamily="34" charset="-122"/>
                 <a:cs typeface="Arial" pitchFamily="34" charset="-120"/>
               </a:rPr>
-              <a:t>4.2 · المرحلة 3</a:t>
-            </a:r>
-            <a:endParaRPr lang="ar-SA" sz="650" dirty="0"/>
+              <a:t>المرحلة 3 – إصدار تصريح العمل</a:t>
+            </a:r>
+            <a:endParaRPr lang="ar-SA" sz="750" dirty="0"/>
           </a:p>
           <a:p>
             <a:pPr algn="r" indent="0" marL="0">
@@ -5329,7 +5329,7 @@
               </a:rPr>
               <a:t>تعميم التصريح للموافقات</a:t>
             </a:r>
-            <a:endParaRPr lang="ar-SA" sz="650" dirty="0"/>
+            <a:endParaRPr lang="ar-SA" sz="750" dirty="0"/>
           </a:p>
           <a:p>
             <a:pPr algn="r" indent="0" marL="0">
@@ -5349,7 +5349,7 @@
               </a:rPr>
               <a:t>أربعاء 14 أكتوبر</a:t>
             </a:r>
-            <a:endParaRPr lang="ar-SA" sz="650" dirty="0"/>
+            <a:endParaRPr lang="ar-SA" sz="750" dirty="0"/>
           </a:p>
           <a:p>
             <a:pPr algn="r" indent="0" marL="0">
@@ -5369,7 +5369,7 @@
               </a:rPr>
               <a:t>أُرسل تصريح العمل للإدارات المعنية للموافقة عليه.</a:t>
             </a:r>
-            <a:endParaRPr lang="ar-SA" sz="650" dirty="0"/>
+            <a:endParaRPr lang="ar-SA" sz="750" dirty="0"/>
           </a:p>
         </p:txBody>
       </p:sp>
@@ -5560,7 +5560,7 @@
               <a:buNone/>
             </a:pPr>
             <a:r>
-              <a:rPr lang="ar-SA" altLang="en-US" sz="650" b="1" dirty="0">
+              <a:rPr lang="ar-SA" altLang="en-US" sz="750" b="1" dirty="0">
                 <a:solidFill>
                   <a:srgbClr val="2E9E6B"/>
                 </a:solidFill>
@@ -5568,9 +5568,9 @@
                 <a:ea typeface="Arial" pitchFamily="34" charset="-122"/>
                 <a:cs typeface="Arial" pitchFamily="34" charset="-120"/>
               </a:rPr>
-              <a:t>4.3 · المرحلة 3</a:t>
-            </a:r>
-            <a:endParaRPr lang="ar-SA" sz="650" dirty="0"/>
+              <a:t>المرحلة 3 – إصدار تصريح العمل</a:t>
+            </a:r>
+            <a:endParaRPr lang="ar-SA" sz="750" dirty="0"/>
           </a:p>
           <a:p>
             <a:pPr algn="r" indent="0" marL="0">
@@ -5590,7 +5590,7 @@
               </a:rPr>
               <a:t>ملاحظات إضافية من الإدارات</a:t>
             </a:r>
-            <a:endParaRPr lang="ar-SA" sz="650" dirty="0"/>
+            <a:endParaRPr lang="ar-SA" sz="750" dirty="0"/>
           </a:p>
           <a:p>
             <a:pPr algn="r" indent="0" marL="0">
@@ -5610,7 +5610,7 @@
               </a:rPr>
               <a:t>خميس 15 أكتوبر</a:t>
             </a:r>
-            <a:endParaRPr lang="ar-SA" sz="650" dirty="0"/>
+            <a:endParaRPr lang="ar-SA" sz="750" dirty="0"/>
           </a:p>
           <a:p>
             <a:pPr algn="r" indent="0" marL="0">
@@ -5630,7 +5630,7 @@
               </a:rPr>
               <a:t>وردت ملاحظات إضافية من إدارات أخرى.</a:t>
             </a:r>
-            <a:endParaRPr lang="ar-SA" sz="650" dirty="0"/>
+            <a:endParaRPr lang="ar-SA" sz="750" dirty="0"/>
           </a:p>
         </p:txBody>
       </p:sp>
@@ -5821,7 +5821,7 @@
               <a:buNone/>
             </a:pPr>
             <a:r>
-              <a:rPr lang="ar-SA" altLang="en-US" sz="650" b="1" dirty="0">
+              <a:rPr lang="ar-SA" altLang="en-US" sz="750" b="1" dirty="0">
                 <a:solidFill>
                   <a:srgbClr val="2E9E6B"/>
                 </a:solidFill>
@@ -5829,9 +5829,9 @@
                 <a:ea typeface="Arial" pitchFamily="34" charset="-122"/>
                 <a:cs typeface="Arial" pitchFamily="34" charset="-120"/>
               </a:rPr>
-              <a:t>4.4 · المرحلة 3</a:t>
-            </a:r>
-            <a:endParaRPr lang="ar-SA" sz="650" dirty="0"/>
+              <a:t>المرحلة 3 – إصدار تصريح العمل</a:t>
+            </a:r>
+            <a:endParaRPr lang="ar-SA" sz="750" dirty="0"/>
           </a:p>
           <a:p>
             <a:pPr algn="r" indent="0" marL="0">
@@ -5851,7 +5851,7 @@
               </a:rPr>
               <a:t>تقديم المراجعة الثالثة (MoS)</a:t>
             </a:r>
-            <a:endParaRPr lang="ar-SA" sz="650" dirty="0"/>
+            <a:endParaRPr lang="ar-SA" sz="750" dirty="0"/>
           </a:p>
           <a:p>
             <a:pPr algn="r" indent="0" marL="0">
@@ -5871,7 +5871,7 @@
               </a:rPr>
               <a:t>اثنين 19 أكتوبر</a:t>
             </a:r>
-            <a:endParaRPr lang="ar-SA" sz="650" dirty="0"/>
+            <a:endParaRPr lang="ar-SA" sz="750" dirty="0"/>
           </a:p>
           <a:p>
             <a:pPr algn="r" indent="0" marL="0">
@@ -5891,7 +5891,7 @@
               </a:rPr>
               <a:t>قُدّمت المراجعة الثالثة للبيان للجميع للاعتماد.</a:t>
             </a:r>
-            <a:endParaRPr lang="ar-SA" sz="650" dirty="0"/>
+            <a:endParaRPr lang="ar-SA" sz="750" dirty="0"/>
           </a:p>
         </p:txBody>
       </p:sp>
@@ -6082,7 +6082,7 @@
               <a:buNone/>
             </a:pPr>
             <a:r>
-              <a:rPr lang="ar-SA" altLang="en-US" sz="650" b="1" dirty="0">
+              <a:rPr lang="ar-SA" altLang="en-US" sz="750" b="1" dirty="0">
                 <a:solidFill>
                   <a:srgbClr val="2E9E6B"/>
                 </a:solidFill>
@@ -6090,9 +6090,9 @@
                 <a:ea typeface="Arial" pitchFamily="34" charset="-122"/>
                 <a:cs typeface="Arial" pitchFamily="34" charset="-120"/>
               </a:rPr>
-              <a:t>4.5 · المرحلة 3</a:t>
-            </a:r>
-            <a:endParaRPr lang="ar-SA" sz="650" dirty="0"/>
+              <a:t>المرحلة 3 – إصدار تصريح العمل</a:t>
+            </a:r>
+            <a:endParaRPr lang="ar-SA" sz="750" dirty="0"/>
           </a:p>
           <a:p>
             <a:pPr algn="r" indent="0" marL="0">
@@ -6112,7 +6112,7 @@
               </a:rPr>
               <a:t>إغلاق الاستفسار الأخير</a:t>
             </a:r>
-            <a:endParaRPr lang="ar-SA" sz="650" dirty="0"/>
+            <a:endParaRPr lang="ar-SA" sz="750" dirty="0"/>
           </a:p>
           <a:p>
             <a:pPr algn="r" indent="0" marL="0">
@@ -6132,7 +6132,7 @@
               </a:rPr>
               <a:t>ثلاثاء 20 أكتوبر</a:t>
             </a:r>
-            <a:endParaRPr lang="ar-SA" sz="650" dirty="0"/>
+            <a:endParaRPr lang="ar-SA" sz="750" dirty="0"/>
           </a:p>
           <a:p>
             <a:pPr algn="r" indent="0" marL="0">
@@ -6152,7 +6152,7 @@
               </a:rPr>
               <a:t>تم إغلاق الاستفسار المتبقي بشأن بيان طريقة العمل.</a:t>
             </a:r>
-            <a:endParaRPr lang="ar-SA" sz="650" dirty="0"/>
+            <a:endParaRPr lang="ar-SA" sz="750" dirty="0"/>
           </a:p>
         </p:txBody>
       </p:sp>
@@ -6343,7 +6343,7 @@
               <a:buNone/>
             </a:pPr>
             <a:r>
-              <a:rPr lang="ar-SA" altLang="en-US" sz="650" b="1" dirty="0">
+              <a:rPr lang="ar-SA" altLang="en-US" sz="750" b="1" dirty="0">
                 <a:solidFill>
                   <a:srgbClr val="2E9E6B"/>
                 </a:solidFill>
@@ -6351,9 +6351,9 @@
                 <a:ea typeface="Arial" pitchFamily="34" charset="-122"/>
                 <a:cs typeface="Arial" pitchFamily="34" charset="-120"/>
               </a:rPr>
-              <a:t>4.6 · المرحلة 3</a:t>
-            </a:r>
-            <a:endParaRPr lang="ar-SA" sz="650" dirty="0"/>
+              <a:t>المرحلة 3 – إصدار تصريح العمل</a:t>
+            </a:r>
+            <a:endParaRPr lang="ar-SA" sz="750" dirty="0"/>
           </a:p>
           <a:p>
             <a:pPr algn="r" indent="0" marL="0">
@@ -6373,7 +6373,7 @@
               </a:rPr>
               <a:t>تصريح العمل جاهز للتوقيع</a:t>
             </a:r>
-            <a:endParaRPr lang="ar-SA" sz="650" dirty="0"/>
+            <a:endParaRPr lang="ar-SA" sz="750" dirty="0"/>
           </a:p>
           <a:p>
             <a:pPr algn="r" indent="0" marL="0">
@@ -6393,7 +6393,7 @@
               </a:rPr>
               <a:t>أربعاء 21 أكتوبر</a:t>
             </a:r>
-            <a:endParaRPr lang="ar-SA" sz="650" dirty="0"/>
+            <a:endParaRPr lang="ar-SA" sz="750" dirty="0"/>
           </a:p>
           <a:p>
             <a:pPr algn="r" indent="0" marL="0">
@@ -6413,7 +6413,7 @@
               </a:rPr>
               <a:t>أصبح تصريح العمل جاهزاً للتوقيع والإصدار.</a:t>
             </a:r>
-            <a:endParaRPr lang="ar-SA" sz="650" dirty="0"/>
+            <a:endParaRPr lang="ar-SA" sz="750" dirty="0"/>
           </a:p>
         </p:txBody>
       </p:sp>

</xml_diff>

<commit_message>
Timeline: description toggle (hidden by default), remove Event No. chip from boxes
Co-Authored-By: Claude Sonnet 5.5 <noreply@anthropic.com>
Claude-Session: https://claude.ai/code/session_015CooLRRU7X55XCWBXAPEMd
</commit_message>
<xml_diff>
--- a/ufwl-timeline/UFWL_Timeline_AR_sample.pptx
+++ b/ufwl-timeline/UFWL_Timeline_AR_sample.pptx
@@ -2086,12 +2086,12 @@
         </p:nvSpPr>
         <p:spPr>
           <a:xfrm>
-            <a:off x="9899778" y="2532888"/>
-            <a:ext cx="2017597" cy="914400"/>
+            <a:off x="9899778" y="2734056"/>
+            <a:ext cx="2017597" cy="713232"/>
           </a:xfrm>
           <a:prstGeom prst="roundRect">
             <a:avLst>
-              <a:gd name="adj" fmla="val 8000"/>
+              <a:gd name="adj" fmla="val 10256"/>
             </a:avLst>
           </a:prstGeom>
           <a:solidFill>
@@ -2120,7 +2120,7 @@
         </p:nvSpPr>
         <p:spPr>
           <a:xfrm>
-            <a:off x="9972930" y="2532888"/>
+            <a:off x="9972930" y="2734056"/>
             <a:ext cx="1871293" cy="54864"/>
           </a:xfrm>
           <a:prstGeom prst="rect">
@@ -2139,41 +2139,14 @@
       </p:sp>
       <p:sp>
         <p:nvSpPr>
-          <p:cNvPr id="35" name="Shape 33"/>
-          <p:cNvSpPr/>
-          <p:nvPr/>
-        </p:nvSpPr>
-        <p:spPr>
-          <a:xfrm>
-            <a:off x="9991218" y="2624328"/>
-            <a:ext cx="749808" cy="173736"/>
-          </a:xfrm>
-          <a:prstGeom prst="roundRect">
-            <a:avLst>
-              <a:gd name="adj" fmla="val 50000"/>
-            </a:avLst>
-          </a:prstGeom>
-          <a:solidFill>
-            <a:srgbClr val="7A8791"/>
-          </a:solidFill>
-          <a:ln w="12700">
-            <a:solidFill>
-              <a:srgbClr val="7A8791"/>
-            </a:solidFill>
-            <a:prstDash val="solid"/>
-          </a:ln>
-        </p:spPr>
-      </p:sp>
-      <p:sp>
-        <p:nvSpPr>
-          <p:cNvPr id="36" name="Text 34"/>
-          <p:cNvSpPr/>
-          <p:nvPr/>
-        </p:nvSpPr>
-        <p:spPr>
-          <a:xfrm>
-            <a:off x="9991218" y="2624328"/>
-            <a:ext cx="749808" cy="173736"/>
+          <p:cNvPr id="35" name="Text 33"/>
+          <p:cNvSpPr/>
+          <p:nvPr/>
+        </p:nvSpPr>
+        <p:spPr>
+          <a:xfrm>
+            <a:off x="9991218" y="2807208"/>
+            <a:ext cx="1834717" cy="210312"/>
           </a:xfrm>
           <a:prstGeom prst="rect">
             <a:avLst/>
@@ -2187,52 +2160,11 @@
           </a:bodyPr>
           <a:lstStyle/>
           <a:p>
-            <a:pPr rtl="1" algn="ctr" indent="0" marL="0">
-              <a:buNone/>
-            </a:pPr>
-            <a:r>
-              <a:rPr lang="ar-SA" altLang="en-US" sz="650" b="1" dirty="0">
-                <a:solidFill>
-                  <a:srgbClr val="FFFFFF"/>
-                </a:solidFill>
-                <a:latin typeface="Arial" pitchFamily="34" charset="0"/>
-                <a:ea typeface="Arial" pitchFamily="34" charset="-122"/>
-                <a:cs typeface="Arial" pitchFamily="34" charset="-120"/>
-              </a:rPr>
-              <a:t>حدث رقم 1</a:t>
-            </a:r>
-            <a:endParaRPr lang="ar-SA" sz="650" dirty="0"/>
-          </a:p>
-        </p:txBody>
-      </p:sp>
-      <p:sp>
-        <p:nvSpPr>
-          <p:cNvPr id="37" name="Text 35"/>
-          <p:cNvSpPr/>
-          <p:nvPr/>
-        </p:nvSpPr>
-        <p:spPr>
-          <a:xfrm>
-            <a:off x="10786746" y="2606040"/>
-            <a:ext cx="1039189" cy="210312"/>
-          </a:xfrm>
-          <a:prstGeom prst="rect">
-            <a:avLst/>
-          </a:prstGeom>
-          <a:noFill/>
-          <a:ln/>
-        </p:spPr>
-        <p:txBody>
-          <a:bodyPr wrap="square" lIns="0" tIns="0" rIns="0" bIns="0" rtlCol="0" anchor="ctr">
-            <a:normAutofit/>
-          </a:bodyPr>
-          <a:lstStyle/>
-          <a:p>
             <a:pPr rtl="1" algn="r" indent="0" marL="0">
               <a:buNone/>
             </a:pPr>
             <a:r>
-              <a:rPr lang="ar-SA" altLang="en-US" sz="900" b="1" dirty="0">
+              <a:rPr lang="ar-SA" altLang="en-US" sz="950" b="1" dirty="0">
                 <a:solidFill>
                   <a:srgbClr val="3D3935"/>
                 </a:solidFill>
@@ -2242,20 +2174,20 @@
               </a:rPr>
               <a:t>اثنين 31 أغسطس 2026</a:t>
             </a:r>
-            <a:endParaRPr lang="ar-SA" sz="900" dirty="0"/>
-          </a:p>
-        </p:txBody>
-      </p:sp>
-      <p:sp>
-        <p:nvSpPr>
-          <p:cNvPr id="38" name="Text 36"/>
-          <p:cNvSpPr/>
-          <p:nvPr/>
-        </p:nvSpPr>
-        <p:spPr>
-          <a:xfrm>
-            <a:off x="9991218" y="2852928"/>
-            <a:ext cx="1834717" cy="539496"/>
+            <a:endParaRPr lang="ar-SA" sz="950" dirty="0"/>
+          </a:p>
+        </p:txBody>
+      </p:sp>
+      <p:sp>
+        <p:nvSpPr>
+          <p:cNvPr id="36" name="Text 34"/>
+          <p:cNvSpPr/>
+          <p:nvPr/>
+        </p:nvSpPr>
+        <p:spPr>
+          <a:xfrm>
+            <a:off x="9991218" y="3054096"/>
+            <a:ext cx="1834717" cy="338328"/>
           </a:xfrm>
           <a:prstGeom prst="rect">
             <a:avLst/>
@@ -2308,31 +2240,11 @@
             </a:r>
             <a:endParaRPr lang="ar-SA" sz="650" dirty="0"/>
           </a:p>
-          <a:p>
-            <a:pPr algn="r" indent="0" marL="0">
-              <a:spcAft>
-                <a:spcPts val="100"/>
-              </a:spcAft>
-              <a:buNone/>
-            </a:pPr>
-            <a:r>
-              <a:rPr lang="ar-SA" altLang="en-US" sz="700" dirty="0">
-                <a:solidFill>
-                  <a:srgbClr val="444D55"/>
-                </a:solidFill>
-                <a:latin typeface="Arial" pitchFamily="34" charset="0"/>
-                <a:ea typeface="Arial" pitchFamily="34" charset="-122"/>
-                <a:cs typeface="Arial" pitchFamily="34" charset="-120"/>
-              </a:rPr>
-              <a:t>طلب تصريح لتنفيذ أعمال الأساسات لإزالة خطر انهيار التربة.</a:t>
-            </a:r>
-            <a:endParaRPr lang="ar-SA" sz="650" dirty="0"/>
-          </a:p>
-        </p:txBody>
-      </p:sp>
-      <p:sp>
-        <p:nvSpPr>
-          <p:cNvPr id="39" name="Shape 37"/>
+        </p:txBody>
+      </p:sp>
+      <p:sp>
+        <p:nvSpPr>
+          <p:cNvPr id="37" name="Shape 35"/>
           <p:cNvSpPr/>
           <p:nvPr/>
         </p:nvSpPr>
@@ -2357,7 +2269,7 @@
       </p:sp>
       <p:sp>
         <p:nvSpPr>
-          <p:cNvPr id="40" name="Shape 38"/>
+          <p:cNvPr id="38" name="Shape 36"/>
           <p:cNvSpPr/>
           <p:nvPr/>
         </p:nvSpPr>
@@ -2389,7 +2301,7 @@
       </p:sp>
       <p:sp>
         <p:nvSpPr>
-          <p:cNvPr id="41" name="Text 39"/>
+          <p:cNvPr id="39" name="Text 37"/>
           <p:cNvSpPr/>
           <p:nvPr/>
         </p:nvSpPr>
@@ -2430,18 +2342,18 @@
       </p:sp>
       <p:sp>
         <p:nvSpPr>
-          <p:cNvPr id="42" name="Shape 40"/>
+          <p:cNvPr id="40" name="Shape 38"/>
           <p:cNvSpPr/>
           <p:nvPr/>
         </p:nvSpPr>
         <p:spPr>
           <a:xfrm>
             <a:off x="9658000" y="4233672"/>
-            <a:ext cx="2017597" cy="914400"/>
+            <a:ext cx="2017597" cy="713232"/>
           </a:xfrm>
           <a:prstGeom prst="roundRect">
             <a:avLst>
-              <a:gd name="adj" fmla="val 8000"/>
+              <a:gd name="adj" fmla="val 10256"/>
             </a:avLst>
           </a:prstGeom>
           <a:solidFill>
@@ -2464,7 +2376,7 @@
       </p:sp>
       <p:sp>
         <p:nvSpPr>
-          <p:cNvPr id="43" name="Shape 41"/>
+          <p:cNvPr id="41" name="Shape 39"/>
           <p:cNvSpPr/>
           <p:nvPr/>
         </p:nvSpPr>
@@ -2489,41 +2401,14 @@
       </p:sp>
       <p:sp>
         <p:nvSpPr>
-          <p:cNvPr id="44" name="Shape 42"/>
-          <p:cNvSpPr/>
-          <p:nvPr/>
-        </p:nvSpPr>
-        <p:spPr>
-          <a:xfrm>
-            <a:off x="9749440" y="4325112"/>
-            <a:ext cx="749808" cy="173736"/>
-          </a:xfrm>
-          <a:prstGeom prst="roundRect">
-            <a:avLst>
-              <a:gd name="adj" fmla="val 50000"/>
-            </a:avLst>
-          </a:prstGeom>
-          <a:solidFill>
-            <a:srgbClr val="7A8791"/>
-          </a:solidFill>
-          <a:ln w="12700">
-            <a:solidFill>
-              <a:srgbClr val="7A8791"/>
-            </a:solidFill>
-            <a:prstDash val="solid"/>
-          </a:ln>
-        </p:spPr>
-      </p:sp>
-      <p:sp>
-        <p:nvSpPr>
-          <p:cNvPr id="45" name="Text 43"/>
-          <p:cNvSpPr/>
-          <p:nvPr/>
-        </p:nvSpPr>
-        <p:spPr>
-          <a:xfrm>
-            <a:off x="9749440" y="4325112"/>
-            <a:ext cx="749808" cy="173736"/>
+          <p:cNvPr id="42" name="Text 40"/>
+          <p:cNvSpPr/>
+          <p:nvPr/>
+        </p:nvSpPr>
+        <p:spPr>
+          <a:xfrm>
+            <a:off x="9749440" y="4306824"/>
+            <a:ext cx="1834717" cy="210312"/>
           </a:xfrm>
           <a:prstGeom prst="rect">
             <a:avLst/>
@@ -2537,52 +2422,11 @@
           </a:bodyPr>
           <a:lstStyle/>
           <a:p>
-            <a:pPr rtl="1" algn="ctr" indent="0" marL="0">
-              <a:buNone/>
-            </a:pPr>
-            <a:r>
-              <a:rPr lang="ar-SA" altLang="en-US" sz="650" b="1" dirty="0">
-                <a:solidFill>
-                  <a:srgbClr val="FFFFFF"/>
-                </a:solidFill>
-                <a:latin typeface="Arial" pitchFamily="34" charset="0"/>
-                <a:ea typeface="Arial" pitchFamily="34" charset="-122"/>
-                <a:cs typeface="Arial" pitchFamily="34" charset="-120"/>
-              </a:rPr>
-              <a:t>حدث رقم 2</a:t>
-            </a:r>
-            <a:endParaRPr lang="ar-SA" sz="650" dirty="0"/>
-          </a:p>
-        </p:txBody>
-      </p:sp>
-      <p:sp>
-        <p:nvSpPr>
-          <p:cNvPr id="46" name="Text 44"/>
-          <p:cNvSpPr/>
-          <p:nvPr/>
-        </p:nvSpPr>
-        <p:spPr>
-          <a:xfrm>
-            <a:off x="10544968" y="4306824"/>
-            <a:ext cx="1039189" cy="210312"/>
-          </a:xfrm>
-          <a:prstGeom prst="rect">
-            <a:avLst/>
-          </a:prstGeom>
-          <a:noFill/>
-          <a:ln/>
-        </p:spPr>
-        <p:txBody>
-          <a:bodyPr wrap="square" lIns="0" tIns="0" rIns="0" bIns="0" rtlCol="0" anchor="ctr">
-            <a:normAutofit/>
-          </a:bodyPr>
-          <a:lstStyle/>
-          <a:p>
             <a:pPr rtl="1" algn="r" indent="0" marL="0">
               <a:buNone/>
             </a:pPr>
             <a:r>
-              <a:rPr lang="ar-SA" altLang="en-US" sz="900" b="1" dirty="0">
+              <a:rPr lang="ar-SA" altLang="en-US" sz="950" b="1" dirty="0">
                 <a:solidFill>
                   <a:srgbClr val="3D3935"/>
                 </a:solidFill>
@@ -2592,20 +2436,20 @@
               </a:rPr>
               <a:t>اثنين 28 سبتمبر 2026</a:t>
             </a:r>
-            <a:endParaRPr lang="ar-SA" sz="900" dirty="0"/>
-          </a:p>
-        </p:txBody>
-      </p:sp>
-      <p:sp>
-        <p:nvSpPr>
-          <p:cNvPr id="47" name="Text 45"/>
+            <a:endParaRPr lang="ar-SA" sz="950" dirty="0"/>
+          </a:p>
+        </p:txBody>
+      </p:sp>
+      <p:sp>
+        <p:nvSpPr>
+          <p:cNvPr id="43" name="Text 41"/>
           <p:cNvSpPr/>
           <p:nvPr/>
         </p:nvSpPr>
         <p:spPr>
           <a:xfrm>
             <a:off x="9749440" y="4553712"/>
-            <a:ext cx="1834717" cy="539496"/>
+            <a:ext cx="1834717" cy="338328"/>
           </a:xfrm>
           <a:prstGeom prst="rect">
             <a:avLst/>
@@ -2658,38 +2502,18 @@
             </a:r>
             <a:endParaRPr lang="ar-SA" sz="650" dirty="0"/>
           </a:p>
-          <a:p>
-            <a:pPr algn="r" indent="0" marL="0">
-              <a:spcAft>
-                <a:spcPts val="100"/>
-              </a:spcAft>
-              <a:buNone/>
-            </a:pPr>
-            <a:r>
-              <a:rPr lang="ar-SA" altLang="en-US" sz="700" dirty="0">
-                <a:solidFill>
-                  <a:srgbClr val="444D55"/>
-                </a:solidFill>
-                <a:latin typeface="Arial" pitchFamily="34" charset="0"/>
-                <a:ea typeface="Arial" pitchFamily="34" charset="-122"/>
-                <a:cs typeface="Arial" pitchFamily="34" charset="-120"/>
-              </a:rPr>
-              <a:t>رفضت إدارة التصاريح طلب تصريح العمل.</a:t>
-            </a:r>
-            <a:endParaRPr lang="ar-SA" sz="650" dirty="0"/>
-          </a:p>
-        </p:txBody>
-      </p:sp>
-      <p:sp>
-        <p:nvSpPr>
-          <p:cNvPr id="48" name="Shape 46"/>
-          <p:cNvSpPr/>
-          <p:nvPr/>
-        </p:nvSpPr>
-        <p:spPr>
-          <a:xfrm>
-            <a:off x="10015961" y="2423160"/>
-            <a:ext cx="0" cy="1207008"/>
+        </p:txBody>
+      </p:sp>
+      <p:sp>
+        <p:nvSpPr>
+          <p:cNvPr id="44" name="Shape 42"/>
+          <p:cNvSpPr/>
+          <p:nvPr/>
+        </p:nvSpPr>
+        <p:spPr>
+          <a:xfrm>
+            <a:off x="10015961" y="2624328"/>
+            <a:ext cx="0" cy="1005840"/>
           </a:xfrm>
           <a:prstGeom prst="line">
             <a:avLst/>
@@ -2707,7 +2531,7 @@
       </p:sp>
       <p:sp>
         <p:nvSpPr>
-          <p:cNvPr id="49" name="Shape 47"/>
+          <p:cNvPr id="45" name="Shape 43"/>
           <p:cNvSpPr/>
           <p:nvPr/>
         </p:nvSpPr>
@@ -2739,7 +2563,7 @@
       </p:sp>
       <p:sp>
         <p:nvSpPr>
-          <p:cNvPr id="50" name="Text 48"/>
+          <p:cNvPr id="46" name="Text 44"/>
           <p:cNvSpPr/>
           <p:nvPr/>
         </p:nvSpPr>
@@ -2780,18 +2604,18 @@
       </p:sp>
       <p:sp>
         <p:nvSpPr>
-          <p:cNvPr id="51" name="Shape 49"/>
-          <p:cNvSpPr/>
-          <p:nvPr/>
-        </p:nvSpPr>
-        <p:spPr>
-          <a:xfrm>
-            <a:off x="9007163" y="1508760"/>
-            <a:ext cx="2017597" cy="914400"/>
+          <p:cNvPr id="47" name="Shape 45"/>
+          <p:cNvSpPr/>
+          <p:nvPr/>
+        </p:nvSpPr>
+        <p:spPr>
+          <a:xfrm>
+            <a:off x="9007163" y="1911096"/>
+            <a:ext cx="2017597" cy="713232"/>
           </a:xfrm>
           <a:prstGeom prst="roundRect">
             <a:avLst>
-              <a:gd name="adj" fmla="val 8000"/>
+              <a:gd name="adj" fmla="val 10256"/>
             </a:avLst>
           </a:prstGeom>
           <a:solidFill>
@@ -2814,13 +2638,13 @@
       </p:sp>
       <p:sp>
         <p:nvSpPr>
-          <p:cNvPr id="52" name="Shape 50"/>
-          <p:cNvSpPr/>
-          <p:nvPr/>
-        </p:nvSpPr>
-        <p:spPr>
-          <a:xfrm>
-            <a:off x="9080315" y="1508760"/>
+          <p:cNvPr id="48" name="Shape 46"/>
+          <p:cNvSpPr/>
+          <p:nvPr/>
+        </p:nvSpPr>
+        <p:spPr>
+          <a:xfrm>
+            <a:off x="9080315" y="1911096"/>
             <a:ext cx="1871293" cy="54864"/>
           </a:xfrm>
           <a:prstGeom prst="rect">
@@ -2839,41 +2663,14 @@
       </p:sp>
       <p:sp>
         <p:nvSpPr>
-          <p:cNvPr id="53" name="Shape 51"/>
-          <p:cNvSpPr/>
-          <p:nvPr/>
-        </p:nvSpPr>
-        <p:spPr>
-          <a:xfrm>
-            <a:off x="9098603" y="1600200"/>
-            <a:ext cx="749808" cy="173736"/>
-          </a:xfrm>
-          <a:prstGeom prst="roundRect">
-            <a:avLst>
-              <a:gd name="adj" fmla="val 50000"/>
-            </a:avLst>
-          </a:prstGeom>
-          <a:solidFill>
-            <a:srgbClr val="C8503F"/>
-          </a:solidFill>
-          <a:ln w="12700">
-            <a:solidFill>
-              <a:srgbClr val="C8503F"/>
-            </a:solidFill>
-            <a:prstDash val="solid"/>
-          </a:ln>
-        </p:spPr>
-      </p:sp>
-      <p:sp>
-        <p:nvSpPr>
-          <p:cNvPr id="54" name="Text 52"/>
-          <p:cNvSpPr/>
-          <p:nvPr/>
-        </p:nvSpPr>
-        <p:spPr>
-          <a:xfrm>
-            <a:off x="9098603" y="1600200"/>
-            <a:ext cx="749808" cy="173736"/>
+          <p:cNvPr id="49" name="Text 47"/>
+          <p:cNvSpPr/>
+          <p:nvPr/>
+        </p:nvSpPr>
+        <p:spPr>
+          <a:xfrm>
+            <a:off x="9098603" y="1984248"/>
+            <a:ext cx="1834717" cy="210312"/>
           </a:xfrm>
           <a:prstGeom prst="rect">
             <a:avLst/>
@@ -2887,52 +2684,11 @@
           </a:bodyPr>
           <a:lstStyle/>
           <a:p>
-            <a:pPr rtl="1" algn="ctr" indent="0" marL="0">
-              <a:buNone/>
-            </a:pPr>
-            <a:r>
-              <a:rPr lang="ar-SA" altLang="en-US" sz="650" b="1" dirty="0">
-                <a:solidFill>
-                  <a:srgbClr val="FFFFFF"/>
-                </a:solidFill>
-                <a:latin typeface="Arial" pitchFamily="34" charset="0"/>
-                <a:ea typeface="Arial" pitchFamily="34" charset="-122"/>
-                <a:cs typeface="Arial" pitchFamily="34" charset="-120"/>
-              </a:rPr>
-              <a:t>حدث رقم 3</a:t>
-            </a:r>
-            <a:endParaRPr lang="ar-SA" sz="650" dirty="0"/>
-          </a:p>
-        </p:txBody>
-      </p:sp>
-      <p:sp>
-        <p:nvSpPr>
-          <p:cNvPr id="55" name="Text 53"/>
-          <p:cNvSpPr/>
-          <p:nvPr/>
-        </p:nvSpPr>
-        <p:spPr>
-          <a:xfrm>
-            <a:off x="9894131" y="1581912"/>
-            <a:ext cx="1039189" cy="210312"/>
-          </a:xfrm>
-          <a:prstGeom prst="rect">
-            <a:avLst/>
-          </a:prstGeom>
-          <a:noFill/>
-          <a:ln/>
-        </p:spPr>
-        <p:txBody>
-          <a:bodyPr wrap="square" lIns="0" tIns="0" rIns="0" bIns="0" rtlCol="0" anchor="ctr">
-            <a:normAutofit/>
-          </a:bodyPr>
-          <a:lstStyle/>
-          <a:p>
             <a:pPr rtl="1" algn="r" indent="0" marL="0">
               <a:buNone/>
             </a:pPr>
             <a:r>
-              <a:rPr lang="ar-SA" altLang="en-US" sz="900" b="1" dirty="0">
+              <a:rPr lang="ar-SA" altLang="en-US" sz="950" b="1" dirty="0">
                 <a:solidFill>
                   <a:srgbClr val="3D3935"/>
                 </a:solidFill>
@@ -2942,20 +2698,20 @@
               </a:rPr>
               <a:t>خميس 1 أكتوبر 2026</a:t>
             </a:r>
-            <a:endParaRPr lang="ar-SA" sz="900" dirty="0"/>
-          </a:p>
-        </p:txBody>
-      </p:sp>
-      <p:sp>
-        <p:nvSpPr>
-          <p:cNvPr id="56" name="Text 54"/>
-          <p:cNvSpPr/>
-          <p:nvPr/>
-        </p:nvSpPr>
-        <p:spPr>
-          <a:xfrm>
-            <a:off x="9098603" y="1828800"/>
-            <a:ext cx="1834717" cy="539496"/>
+            <a:endParaRPr lang="ar-SA" sz="950" dirty="0"/>
+          </a:p>
+        </p:txBody>
+      </p:sp>
+      <p:sp>
+        <p:nvSpPr>
+          <p:cNvPr id="50" name="Text 48"/>
+          <p:cNvSpPr/>
+          <p:nvPr/>
+        </p:nvSpPr>
+        <p:spPr>
+          <a:xfrm>
+            <a:off x="9098603" y="2231136"/>
+            <a:ext cx="1834717" cy="338328"/>
           </a:xfrm>
           <a:prstGeom prst="rect">
             <a:avLst/>
@@ -3008,38 +2764,18 @@
             </a:r>
             <a:endParaRPr lang="ar-SA" sz="650" dirty="0"/>
           </a:p>
-          <a:p>
-            <a:pPr algn="r" indent="0" marL="0">
-              <a:spcAft>
-                <a:spcPts val="100"/>
-              </a:spcAft>
-              <a:buNone/>
-            </a:pPr>
-            <a:r>
-              <a:rPr lang="ar-SA" altLang="en-US" sz="700" dirty="0">
-                <a:solidFill>
-                  <a:srgbClr val="444D55"/>
-                </a:solidFill>
-                <a:latin typeface="Arial" pitchFamily="34" charset="0"/>
-                <a:ea typeface="Arial" pitchFamily="34" charset="-122"/>
-                <a:cs typeface="Arial" pitchFamily="34" charset="-120"/>
-              </a:rPr>
-              <a:t>أوقفت إدارة التصاريح والسلامة جميع أنشطة المشروع بالموقع.</a:t>
-            </a:r>
-            <a:endParaRPr lang="ar-SA" sz="650" dirty="0"/>
-          </a:p>
-        </p:txBody>
-      </p:sp>
-      <p:sp>
-        <p:nvSpPr>
-          <p:cNvPr id="57" name="Shape 55"/>
+        </p:txBody>
+      </p:sp>
+      <p:sp>
+        <p:nvSpPr>
+          <p:cNvPr id="51" name="Shape 49"/>
           <p:cNvSpPr/>
           <p:nvPr/>
         </p:nvSpPr>
         <p:spPr>
           <a:xfrm>
             <a:off x="9365123" y="4050792"/>
-            <a:ext cx="0" cy="1207008"/>
+            <a:ext cx="0" cy="1005840"/>
           </a:xfrm>
           <a:prstGeom prst="line">
             <a:avLst/>
@@ -3057,7 +2793,7 @@
       </p:sp>
       <p:sp>
         <p:nvSpPr>
-          <p:cNvPr id="58" name="Shape 56"/>
+          <p:cNvPr id="52" name="Shape 50"/>
           <p:cNvSpPr/>
           <p:nvPr/>
         </p:nvSpPr>
@@ -3089,7 +2825,7 @@
       </p:sp>
       <p:sp>
         <p:nvSpPr>
-          <p:cNvPr id="59" name="Text 57"/>
+          <p:cNvPr id="53" name="Text 51"/>
           <p:cNvSpPr/>
           <p:nvPr/>
         </p:nvSpPr>
@@ -3130,18 +2866,18 @@
       </p:sp>
       <p:sp>
         <p:nvSpPr>
-          <p:cNvPr id="60" name="Shape 58"/>
-          <p:cNvSpPr/>
-          <p:nvPr/>
-        </p:nvSpPr>
-        <p:spPr>
-          <a:xfrm>
-            <a:off x="8356325" y="5257800"/>
-            <a:ext cx="2017597" cy="914400"/>
+          <p:cNvPr id="54" name="Shape 52"/>
+          <p:cNvSpPr/>
+          <p:nvPr/>
+        </p:nvSpPr>
+        <p:spPr>
+          <a:xfrm>
+            <a:off x="8356325" y="5056632"/>
+            <a:ext cx="2017597" cy="713232"/>
           </a:xfrm>
           <a:prstGeom prst="roundRect">
             <a:avLst>
-              <a:gd name="adj" fmla="val 8000"/>
+              <a:gd name="adj" fmla="val 10256"/>
             </a:avLst>
           </a:prstGeom>
           <a:solidFill>
@@ -3164,13 +2900,13 @@
       </p:sp>
       <p:sp>
         <p:nvSpPr>
-          <p:cNvPr id="61" name="Shape 59"/>
-          <p:cNvSpPr/>
-          <p:nvPr/>
-        </p:nvSpPr>
-        <p:spPr>
-          <a:xfrm>
-            <a:off x="8429477" y="5257800"/>
+          <p:cNvPr id="55" name="Shape 53"/>
+          <p:cNvSpPr/>
+          <p:nvPr/>
+        </p:nvSpPr>
+        <p:spPr>
+          <a:xfrm>
+            <a:off x="8429477" y="5056632"/>
             <a:ext cx="1871293" cy="54864"/>
           </a:xfrm>
           <a:prstGeom prst="rect">
@@ -3189,41 +2925,14 @@
       </p:sp>
       <p:sp>
         <p:nvSpPr>
-          <p:cNvPr id="62" name="Shape 60"/>
-          <p:cNvSpPr/>
-          <p:nvPr/>
-        </p:nvSpPr>
-        <p:spPr>
-          <a:xfrm>
-            <a:off x="8447765" y="5349240"/>
-            <a:ext cx="749808" cy="173736"/>
-          </a:xfrm>
-          <a:prstGeom prst="roundRect">
-            <a:avLst>
-              <a:gd name="adj" fmla="val 50000"/>
-            </a:avLst>
-          </a:prstGeom>
-          <a:solidFill>
-            <a:srgbClr val="C8503F"/>
-          </a:solidFill>
-          <a:ln w="12700">
-            <a:solidFill>
-              <a:srgbClr val="C8503F"/>
-            </a:solidFill>
-            <a:prstDash val="solid"/>
-          </a:ln>
-        </p:spPr>
-      </p:sp>
-      <p:sp>
-        <p:nvSpPr>
-          <p:cNvPr id="63" name="Text 61"/>
-          <p:cNvSpPr/>
-          <p:nvPr/>
-        </p:nvSpPr>
-        <p:spPr>
-          <a:xfrm>
-            <a:off x="8447765" y="5349240"/>
-            <a:ext cx="749808" cy="173736"/>
+          <p:cNvPr id="56" name="Text 54"/>
+          <p:cNvSpPr/>
+          <p:nvPr/>
+        </p:nvSpPr>
+        <p:spPr>
+          <a:xfrm>
+            <a:off x="8447765" y="5129784"/>
+            <a:ext cx="1834717" cy="210312"/>
           </a:xfrm>
           <a:prstGeom prst="rect">
             <a:avLst/>
@@ -3237,52 +2946,11 @@
           </a:bodyPr>
           <a:lstStyle/>
           <a:p>
-            <a:pPr rtl="1" algn="ctr" indent="0" marL="0">
-              <a:buNone/>
-            </a:pPr>
-            <a:r>
-              <a:rPr lang="ar-SA" altLang="en-US" sz="650" b="1" dirty="0">
-                <a:solidFill>
-                  <a:srgbClr val="FFFFFF"/>
-                </a:solidFill>
-                <a:latin typeface="Arial" pitchFamily="34" charset="0"/>
-                <a:ea typeface="Arial" pitchFamily="34" charset="-122"/>
-                <a:cs typeface="Arial" pitchFamily="34" charset="-120"/>
-              </a:rPr>
-              <a:t>حدث رقم 4</a:t>
-            </a:r>
-            <a:endParaRPr lang="ar-SA" sz="650" dirty="0"/>
-          </a:p>
-        </p:txBody>
-      </p:sp>
-      <p:sp>
-        <p:nvSpPr>
-          <p:cNvPr id="64" name="Text 62"/>
-          <p:cNvSpPr/>
-          <p:nvPr/>
-        </p:nvSpPr>
-        <p:spPr>
-          <a:xfrm>
-            <a:off x="9243293" y="5330952"/>
-            <a:ext cx="1039189" cy="210312"/>
-          </a:xfrm>
-          <a:prstGeom prst="rect">
-            <a:avLst/>
-          </a:prstGeom>
-          <a:noFill/>
-          <a:ln/>
-        </p:spPr>
-        <p:txBody>
-          <a:bodyPr wrap="square" lIns="0" tIns="0" rIns="0" bIns="0" rtlCol="0" anchor="ctr">
-            <a:normAutofit/>
-          </a:bodyPr>
-          <a:lstStyle/>
-          <a:p>
             <a:pPr rtl="1" algn="r" indent="0" marL="0">
               <a:buNone/>
             </a:pPr>
             <a:r>
-              <a:rPr lang="ar-SA" altLang="en-US" sz="900" b="1" dirty="0">
+              <a:rPr lang="ar-SA" altLang="en-US" sz="950" b="1" dirty="0">
                 <a:solidFill>
                   <a:srgbClr val="3D3935"/>
                 </a:solidFill>
@@ -3292,20 +2960,20 @@
               </a:rPr>
               <a:t>سبت 3 أكتوبر 2026</a:t>
             </a:r>
-            <a:endParaRPr lang="ar-SA" sz="900" dirty="0"/>
-          </a:p>
-        </p:txBody>
-      </p:sp>
-      <p:sp>
-        <p:nvSpPr>
-          <p:cNvPr id="65" name="Text 63"/>
-          <p:cNvSpPr/>
-          <p:nvPr/>
-        </p:nvSpPr>
-        <p:spPr>
-          <a:xfrm>
-            <a:off x="8447765" y="5577840"/>
-            <a:ext cx="1834717" cy="539496"/>
+            <a:endParaRPr lang="ar-SA" sz="950" dirty="0"/>
+          </a:p>
+        </p:txBody>
+      </p:sp>
+      <p:sp>
+        <p:nvSpPr>
+          <p:cNvPr id="57" name="Text 55"/>
+          <p:cNvSpPr/>
+          <p:nvPr/>
+        </p:nvSpPr>
+        <p:spPr>
+          <a:xfrm>
+            <a:off x="8447765" y="5376672"/>
+            <a:ext cx="1834717" cy="338328"/>
           </a:xfrm>
           <a:prstGeom prst="rect">
             <a:avLst/>
@@ -3358,31 +3026,11 @@
             </a:r>
             <a:endParaRPr lang="ar-SA" sz="650" dirty="0"/>
           </a:p>
-          <a:p>
-            <a:pPr algn="r" indent="0" marL="0">
-              <a:spcAft>
-                <a:spcPts val="100"/>
-              </a:spcAft>
-              <a:buNone/>
-            </a:pPr>
-            <a:r>
-              <a:rPr lang="ar-SA" altLang="en-US" sz="700" dirty="0">
-                <a:solidFill>
-                  <a:srgbClr val="444D55"/>
-                </a:solidFill>
-                <a:latin typeface="Arial" pitchFamily="34" charset="0"/>
-                <a:ea typeface="Arial" pitchFamily="34" charset="-122"/>
-                <a:cs typeface="Arial" pitchFamily="34" charset="-120"/>
-              </a:rPr>
-              <a:t>زيارة مشتركة مع الإدارات المعنية (التصاريح وغيرها) لتقييم حالة الموقع.</a:t>
-            </a:r>
-            <a:endParaRPr lang="ar-SA" sz="650" dirty="0"/>
-          </a:p>
-        </p:txBody>
-      </p:sp>
-      <p:sp>
-        <p:nvSpPr>
-          <p:cNvPr id="66" name="Shape 64"/>
+        </p:txBody>
+      </p:sp>
+      <p:sp>
+        <p:nvSpPr>
+          <p:cNvPr id="58" name="Shape 56"/>
           <p:cNvSpPr/>
           <p:nvPr/>
         </p:nvSpPr>
@@ -3407,7 +3055,7 @@
       </p:sp>
       <p:sp>
         <p:nvSpPr>
-          <p:cNvPr id="67" name="Shape 65"/>
+          <p:cNvPr id="59" name="Shape 57"/>
           <p:cNvSpPr/>
           <p:nvPr/>
         </p:nvSpPr>
@@ -3439,7 +3087,7 @@
       </p:sp>
       <p:sp>
         <p:nvSpPr>
-          <p:cNvPr id="68" name="Text 66"/>
+          <p:cNvPr id="60" name="Text 58"/>
           <p:cNvSpPr/>
           <p:nvPr/>
         </p:nvSpPr>
@@ -3480,18 +3128,18 @@
       </p:sp>
       <p:sp>
         <p:nvSpPr>
-          <p:cNvPr id="69" name="Shape 67"/>
-          <p:cNvSpPr/>
-          <p:nvPr/>
-        </p:nvSpPr>
-        <p:spPr>
-          <a:xfrm>
-            <a:off x="7705487" y="2532888"/>
-            <a:ext cx="2017597" cy="914400"/>
+          <p:cNvPr id="61" name="Shape 59"/>
+          <p:cNvSpPr/>
+          <p:nvPr/>
+        </p:nvSpPr>
+        <p:spPr>
+          <a:xfrm>
+            <a:off x="7705487" y="2734056"/>
+            <a:ext cx="2017597" cy="713232"/>
           </a:xfrm>
           <a:prstGeom prst="roundRect">
             <a:avLst>
-              <a:gd name="adj" fmla="val 8000"/>
+              <a:gd name="adj" fmla="val 10256"/>
             </a:avLst>
           </a:prstGeom>
           <a:solidFill>
@@ -3514,13 +3162,13 @@
       </p:sp>
       <p:sp>
         <p:nvSpPr>
-          <p:cNvPr id="70" name="Shape 68"/>
-          <p:cNvSpPr/>
-          <p:nvPr/>
-        </p:nvSpPr>
-        <p:spPr>
-          <a:xfrm>
-            <a:off x="7778639" y="2532888"/>
+          <p:cNvPr id="62" name="Shape 60"/>
+          <p:cNvSpPr/>
+          <p:nvPr/>
+        </p:nvSpPr>
+        <p:spPr>
+          <a:xfrm>
+            <a:off x="7778639" y="2734056"/>
             <a:ext cx="1871293" cy="54864"/>
           </a:xfrm>
           <a:prstGeom prst="rect">
@@ -3539,41 +3187,14 @@
       </p:sp>
       <p:sp>
         <p:nvSpPr>
-          <p:cNvPr id="71" name="Shape 69"/>
-          <p:cNvSpPr/>
-          <p:nvPr/>
-        </p:nvSpPr>
-        <p:spPr>
-          <a:xfrm>
-            <a:off x="7796927" y="2624328"/>
-            <a:ext cx="749808" cy="173736"/>
-          </a:xfrm>
-          <a:prstGeom prst="roundRect">
-            <a:avLst>
-              <a:gd name="adj" fmla="val 50000"/>
-            </a:avLst>
-          </a:prstGeom>
-          <a:solidFill>
-            <a:srgbClr val="C8503F"/>
-          </a:solidFill>
-          <a:ln w="12700">
-            <a:solidFill>
-              <a:srgbClr val="C8503F"/>
-            </a:solidFill>
-            <a:prstDash val="solid"/>
-          </a:ln>
-        </p:spPr>
-      </p:sp>
-      <p:sp>
-        <p:nvSpPr>
-          <p:cNvPr id="72" name="Text 70"/>
-          <p:cNvSpPr/>
-          <p:nvPr/>
-        </p:nvSpPr>
-        <p:spPr>
-          <a:xfrm>
-            <a:off x="7796927" y="2624328"/>
-            <a:ext cx="749808" cy="173736"/>
+          <p:cNvPr id="63" name="Text 61"/>
+          <p:cNvSpPr/>
+          <p:nvPr/>
+        </p:nvSpPr>
+        <p:spPr>
+          <a:xfrm>
+            <a:off x="7796927" y="2807208"/>
+            <a:ext cx="1834717" cy="210312"/>
           </a:xfrm>
           <a:prstGeom prst="rect">
             <a:avLst/>
@@ -3587,52 +3208,11 @@
           </a:bodyPr>
           <a:lstStyle/>
           <a:p>
-            <a:pPr rtl="1" algn="ctr" indent="0" marL="0">
-              <a:buNone/>
-            </a:pPr>
-            <a:r>
-              <a:rPr lang="ar-SA" altLang="en-US" sz="650" b="1" dirty="0">
-                <a:solidFill>
-                  <a:srgbClr val="FFFFFF"/>
-                </a:solidFill>
-                <a:latin typeface="Arial" pitchFamily="34" charset="0"/>
-                <a:ea typeface="Arial" pitchFamily="34" charset="-122"/>
-                <a:cs typeface="Arial" pitchFamily="34" charset="-120"/>
-              </a:rPr>
-              <a:t>حدث رقم 5</a:t>
-            </a:r>
-            <a:endParaRPr lang="ar-SA" sz="650" dirty="0"/>
-          </a:p>
-        </p:txBody>
-      </p:sp>
-      <p:sp>
-        <p:nvSpPr>
-          <p:cNvPr id="73" name="Text 71"/>
-          <p:cNvSpPr/>
-          <p:nvPr/>
-        </p:nvSpPr>
-        <p:spPr>
-          <a:xfrm>
-            <a:off x="8592455" y="2606040"/>
-            <a:ext cx="1039189" cy="210312"/>
-          </a:xfrm>
-          <a:prstGeom prst="rect">
-            <a:avLst/>
-          </a:prstGeom>
-          <a:noFill/>
-          <a:ln/>
-        </p:spPr>
-        <p:txBody>
-          <a:bodyPr wrap="square" lIns="0" tIns="0" rIns="0" bIns="0" rtlCol="0" anchor="ctr">
-            <a:normAutofit/>
-          </a:bodyPr>
-          <a:lstStyle/>
-          <a:p>
             <a:pPr rtl="1" algn="r" indent="0" marL="0">
               <a:buNone/>
             </a:pPr>
             <a:r>
-              <a:rPr lang="ar-SA" altLang="en-US" sz="900" b="1" dirty="0">
+              <a:rPr lang="ar-SA" altLang="en-US" sz="950" b="1" dirty="0">
                 <a:solidFill>
                   <a:srgbClr val="3D3935"/>
                 </a:solidFill>
@@ -3642,20 +3222,20 @@
               </a:rPr>
               <a:t>أحد 4 أكتوبر 2026</a:t>
             </a:r>
-            <a:endParaRPr lang="ar-SA" sz="900" dirty="0"/>
-          </a:p>
-        </p:txBody>
-      </p:sp>
-      <p:sp>
-        <p:nvSpPr>
-          <p:cNvPr id="74" name="Text 72"/>
-          <p:cNvSpPr/>
-          <p:nvPr/>
-        </p:nvSpPr>
-        <p:spPr>
-          <a:xfrm>
-            <a:off x="7796927" y="2852928"/>
-            <a:ext cx="1834717" cy="539496"/>
+            <a:endParaRPr lang="ar-SA" sz="950" dirty="0"/>
+          </a:p>
+        </p:txBody>
+      </p:sp>
+      <p:sp>
+        <p:nvSpPr>
+          <p:cNvPr id="64" name="Text 62"/>
+          <p:cNvSpPr/>
+          <p:nvPr/>
+        </p:nvSpPr>
+        <p:spPr>
+          <a:xfrm>
+            <a:off x="7796927" y="3054096"/>
+            <a:ext cx="1834717" cy="338328"/>
           </a:xfrm>
           <a:prstGeom prst="rect">
             <a:avLst/>
@@ -3708,31 +3288,11 @@
             </a:r>
             <a:endParaRPr lang="ar-SA" sz="650" dirty="0"/>
           </a:p>
-          <a:p>
-            <a:pPr algn="r" indent="0" marL="0">
-              <a:spcAft>
-                <a:spcPts val="100"/>
-              </a:spcAft>
-              <a:buNone/>
-            </a:pPr>
-            <a:r>
-              <a:rPr lang="ar-SA" altLang="en-US" sz="700" dirty="0">
-                <a:solidFill>
-                  <a:srgbClr val="444D55"/>
-                </a:solidFill>
-                <a:latin typeface="Arial" pitchFamily="34" charset="0"/>
-                <a:ea typeface="Arial" pitchFamily="34" charset="-122"/>
-                <a:cs typeface="Arial" pitchFamily="34" charset="-120"/>
-              </a:rPr>
-              <a:t>أُرسلت إلى إدارة التصاريح بهدف استئناف العمل.</a:t>
-            </a:r>
-            <a:endParaRPr lang="ar-SA" sz="650" dirty="0"/>
-          </a:p>
-        </p:txBody>
-      </p:sp>
-      <p:sp>
-        <p:nvSpPr>
-          <p:cNvPr id="75" name="Shape 73"/>
+        </p:txBody>
+      </p:sp>
+      <p:sp>
+        <p:nvSpPr>
+          <p:cNvPr id="65" name="Shape 63"/>
           <p:cNvSpPr/>
           <p:nvPr/>
         </p:nvSpPr>
@@ -3757,7 +3317,7 @@
       </p:sp>
       <p:sp>
         <p:nvSpPr>
-          <p:cNvPr id="76" name="Shape 74"/>
+          <p:cNvPr id="66" name="Shape 64"/>
           <p:cNvSpPr/>
           <p:nvPr/>
         </p:nvSpPr>
@@ -3789,7 +3349,7 @@
       </p:sp>
       <p:sp>
         <p:nvSpPr>
-          <p:cNvPr id="77" name="Text 75"/>
+          <p:cNvPr id="67" name="Text 65"/>
           <p:cNvSpPr/>
           <p:nvPr/>
         </p:nvSpPr>
@@ -3830,18 +3390,18 @@
       </p:sp>
       <p:sp>
         <p:nvSpPr>
-          <p:cNvPr id="78" name="Shape 76"/>
+          <p:cNvPr id="68" name="Shape 66"/>
           <p:cNvSpPr/>
           <p:nvPr/>
         </p:nvSpPr>
         <p:spPr>
           <a:xfrm>
             <a:off x="7054650" y="4233672"/>
-            <a:ext cx="2017597" cy="914400"/>
+            <a:ext cx="2017597" cy="713232"/>
           </a:xfrm>
           <a:prstGeom prst="roundRect">
             <a:avLst>
-              <a:gd name="adj" fmla="val 8000"/>
+              <a:gd name="adj" fmla="val 10256"/>
             </a:avLst>
           </a:prstGeom>
           <a:solidFill>
@@ -3864,7 +3424,7 @@
       </p:sp>
       <p:sp>
         <p:nvSpPr>
-          <p:cNvPr id="79" name="Shape 77"/>
+          <p:cNvPr id="69" name="Shape 67"/>
           <p:cNvSpPr/>
           <p:nvPr/>
         </p:nvSpPr>
@@ -3889,41 +3449,14 @@
       </p:sp>
       <p:sp>
         <p:nvSpPr>
-          <p:cNvPr id="80" name="Shape 78"/>
-          <p:cNvSpPr/>
-          <p:nvPr/>
-        </p:nvSpPr>
-        <p:spPr>
-          <a:xfrm>
-            <a:off x="7146090" y="4325112"/>
-            <a:ext cx="749808" cy="173736"/>
-          </a:xfrm>
-          <a:prstGeom prst="roundRect">
-            <a:avLst>
-              <a:gd name="adj" fmla="val 50000"/>
-            </a:avLst>
-          </a:prstGeom>
-          <a:solidFill>
-            <a:srgbClr val="C8503F"/>
-          </a:solidFill>
-          <a:ln w="12700">
-            <a:solidFill>
-              <a:srgbClr val="C8503F"/>
-            </a:solidFill>
-            <a:prstDash val="solid"/>
-          </a:ln>
-        </p:spPr>
-      </p:sp>
-      <p:sp>
-        <p:nvSpPr>
-          <p:cNvPr id="81" name="Text 79"/>
-          <p:cNvSpPr/>
-          <p:nvPr/>
-        </p:nvSpPr>
-        <p:spPr>
-          <a:xfrm>
-            <a:off x="7146090" y="4325112"/>
-            <a:ext cx="749808" cy="173736"/>
+          <p:cNvPr id="70" name="Text 68"/>
+          <p:cNvSpPr/>
+          <p:nvPr/>
+        </p:nvSpPr>
+        <p:spPr>
+          <a:xfrm>
+            <a:off x="7146090" y="4306824"/>
+            <a:ext cx="1834717" cy="210312"/>
           </a:xfrm>
           <a:prstGeom prst="rect">
             <a:avLst/>
@@ -3937,52 +3470,11 @@
           </a:bodyPr>
           <a:lstStyle/>
           <a:p>
-            <a:pPr rtl="1" algn="ctr" indent="0" marL="0">
-              <a:buNone/>
-            </a:pPr>
-            <a:r>
-              <a:rPr lang="ar-SA" altLang="en-US" sz="650" b="1" dirty="0">
-                <a:solidFill>
-                  <a:srgbClr val="FFFFFF"/>
-                </a:solidFill>
-                <a:latin typeface="Arial" pitchFamily="34" charset="0"/>
-                <a:ea typeface="Arial" pitchFamily="34" charset="-122"/>
-                <a:cs typeface="Arial" pitchFamily="34" charset="-120"/>
-              </a:rPr>
-              <a:t>حدث رقم 6</a:t>
-            </a:r>
-            <a:endParaRPr lang="ar-SA" sz="650" dirty="0"/>
-          </a:p>
-        </p:txBody>
-      </p:sp>
-      <p:sp>
-        <p:nvSpPr>
-          <p:cNvPr id="82" name="Text 80"/>
-          <p:cNvSpPr/>
-          <p:nvPr/>
-        </p:nvSpPr>
-        <p:spPr>
-          <a:xfrm>
-            <a:off x="7941618" y="4306824"/>
-            <a:ext cx="1039189" cy="210312"/>
-          </a:xfrm>
-          <a:prstGeom prst="rect">
-            <a:avLst/>
-          </a:prstGeom>
-          <a:noFill/>
-          <a:ln/>
-        </p:spPr>
-        <p:txBody>
-          <a:bodyPr wrap="square" lIns="0" tIns="0" rIns="0" bIns="0" rtlCol="0" anchor="ctr">
-            <a:normAutofit/>
-          </a:bodyPr>
-          <a:lstStyle/>
-          <a:p>
             <a:pPr rtl="1" algn="r" indent="0" marL="0">
               <a:buNone/>
             </a:pPr>
             <a:r>
-              <a:rPr lang="ar-SA" altLang="en-US" sz="900" b="1" dirty="0">
+              <a:rPr lang="ar-SA" altLang="en-US" sz="950" b="1" dirty="0">
                 <a:solidFill>
                   <a:srgbClr val="3D3935"/>
                 </a:solidFill>
@@ -3992,20 +3484,20 @@
               </a:rPr>
               <a:t>اثنين 5 أكتوبر 2026</a:t>
             </a:r>
-            <a:endParaRPr lang="ar-SA" sz="900" dirty="0"/>
-          </a:p>
-        </p:txBody>
-      </p:sp>
-      <p:sp>
-        <p:nvSpPr>
-          <p:cNvPr id="83" name="Text 81"/>
+            <a:endParaRPr lang="ar-SA" sz="950" dirty="0"/>
+          </a:p>
+        </p:txBody>
+      </p:sp>
+      <p:sp>
+        <p:nvSpPr>
+          <p:cNvPr id="71" name="Text 69"/>
           <p:cNvSpPr/>
           <p:nvPr/>
         </p:nvSpPr>
         <p:spPr>
           <a:xfrm>
             <a:off x="7146090" y="4553712"/>
-            <a:ext cx="1834717" cy="539496"/>
+            <a:ext cx="1834717" cy="338328"/>
           </a:xfrm>
           <a:prstGeom prst="rect">
             <a:avLst/>
@@ -4058,38 +3550,18 @@
             </a:r>
             <a:endParaRPr lang="ar-SA" sz="650" dirty="0"/>
           </a:p>
-          <a:p>
-            <a:pPr algn="r" indent="0" marL="0">
-              <a:spcAft>
-                <a:spcPts val="100"/>
-              </a:spcAft>
-              <a:buNone/>
-            </a:pPr>
-            <a:r>
-              <a:rPr lang="ar-SA" altLang="en-US" sz="700" dirty="0">
-                <a:solidFill>
-                  <a:srgbClr val="444D55"/>
-                </a:solidFill>
-                <a:latin typeface="Arial" pitchFamily="34" charset="0"/>
-                <a:ea typeface="Arial" pitchFamily="34" charset="-122"/>
-                <a:cs typeface="Arial" pitchFamily="34" charset="-120"/>
-              </a:rPr>
-              <a:t>طلبت إدارة التصاريح خطة عمل أكثر تفصيلاً.</a:t>
-            </a:r>
-            <a:endParaRPr lang="ar-SA" sz="650" dirty="0"/>
-          </a:p>
-        </p:txBody>
-      </p:sp>
-      <p:sp>
-        <p:nvSpPr>
-          <p:cNvPr id="84" name="Shape 82"/>
-          <p:cNvSpPr/>
-          <p:nvPr/>
-        </p:nvSpPr>
-        <p:spPr>
-          <a:xfrm>
-            <a:off x="7412610" y="2423160"/>
-            <a:ext cx="0" cy="1207008"/>
+        </p:txBody>
+      </p:sp>
+      <p:sp>
+        <p:nvSpPr>
+          <p:cNvPr id="72" name="Shape 70"/>
+          <p:cNvSpPr/>
+          <p:nvPr/>
+        </p:nvSpPr>
+        <p:spPr>
+          <a:xfrm>
+            <a:off x="7412610" y="2624328"/>
+            <a:ext cx="0" cy="1005840"/>
           </a:xfrm>
           <a:prstGeom prst="line">
             <a:avLst/>
@@ -4107,7 +3579,7 @@
       </p:sp>
       <p:sp>
         <p:nvSpPr>
-          <p:cNvPr id="85" name="Shape 83"/>
+          <p:cNvPr id="73" name="Shape 71"/>
           <p:cNvSpPr/>
           <p:nvPr/>
         </p:nvSpPr>
@@ -4139,7 +3611,7 @@
       </p:sp>
       <p:sp>
         <p:nvSpPr>
-          <p:cNvPr id="86" name="Text 84"/>
+          <p:cNvPr id="74" name="Text 72"/>
           <p:cNvSpPr/>
           <p:nvPr/>
         </p:nvSpPr>
@@ -4180,18 +3652,18 @@
       </p:sp>
       <p:sp>
         <p:nvSpPr>
-          <p:cNvPr id="87" name="Shape 85"/>
-          <p:cNvSpPr/>
-          <p:nvPr/>
-        </p:nvSpPr>
-        <p:spPr>
-          <a:xfrm>
-            <a:off x="6403812" y="1508760"/>
-            <a:ext cx="2017597" cy="914400"/>
+          <p:cNvPr id="75" name="Shape 73"/>
+          <p:cNvSpPr/>
+          <p:nvPr/>
+        </p:nvSpPr>
+        <p:spPr>
+          <a:xfrm>
+            <a:off x="6403812" y="1911096"/>
+            <a:ext cx="2017597" cy="713232"/>
           </a:xfrm>
           <a:prstGeom prst="roundRect">
             <a:avLst>
-              <a:gd name="adj" fmla="val 8000"/>
+              <a:gd name="adj" fmla="val 10256"/>
             </a:avLst>
           </a:prstGeom>
           <a:solidFill>
@@ -4214,13 +3686,13 @@
       </p:sp>
       <p:sp>
         <p:nvSpPr>
-          <p:cNvPr id="88" name="Shape 86"/>
-          <p:cNvSpPr/>
-          <p:nvPr/>
-        </p:nvSpPr>
-        <p:spPr>
-          <a:xfrm>
-            <a:off x="6476964" y="1508760"/>
+          <p:cNvPr id="76" name="Shape 74"/>
+          <p:cNvSpPr/>
+          <p:nvPr/>
+        </p:nvSpPr>
+        <p:spPr>
+          <a:xfrm>
+            <a:off x="6476964" y="1911096"/>
             <a:ext cx="1871293" cy="54864"/>
           </a:xfrm>
           <a:prstGeom prst="rect">
@@ -4239,41 +3711,14 @@
       </p:sp>
       <p:sp>
         <p:nvSpPr>
-          <p:cNvPr id="89" name="Shape 87"/>
-          <p:cNvSpPr/>
-          <p:nvPr/>
-        </p:nvSpPr>
-        <p:spPr>
-          <a:xfrm>
-            <a:off x="6495252" y="1600200"/>
-            <a:ext cx="749808" cy="173736"/>
-          </a:xfrm>
-          <a:prstGeom prst="roundRect">
-            <a:avLst>
-              <a:gd name="adj" fmla="val 50000"/>
-            </a:avLst>
-          </a:prstGeom>
-          <a:solidFill>
-            <a:srgbClr val="00778B"/>
-          </a:solidFill>
-          <a:ln w="12700">
-            <a:solidFill>
-              <a:srgbClr val="00778B"/>
-            </a:solidFill>
-            <a:prstDash val="solid"/>
-          </a:ln>
-        </p:spPr>
-      </p:sp>
-      <p:sp>
-        <p:nvSpPr>
-          <p:cNvPr id="90" name="Text 88"/>
-          <p:cNvSpPr/>
-          <p:nvPr/>
-        </p:nvSpPr>
-        <p:spPr>
-          <a:xfrm>
-            <a:off x="6495252" y="1600200"/>
-            <a:ext cx="749808" cy="173736"/>
+          <p:cNvPr id="77" name="Text 75"/>
+          <p:cNvSpPr/>
+          <p:nvPr/>
+        </p:nvSpPr>
+        <p:spPr>
+          <a:xfrm>
+            <a:off x="6495252" y="1984248"/>
+            <a:ext cx="1834717" cy="210312"/>
           </a:xfrm>
           <a:prstGeom prst="rect">
             <a:avLst/>
@@ -4287,52 +3732,11 @@
           </a:bodyPr>
           <a:lstStyle/>
           <a:p>
-            <a:pPr rtl="1" algn="ctr" indent="0" marL="0">
-              <a:buNone/>
-            </a:pPr>
-            <a:r>
-              <a:rPr lang="ar-SA" altLang="en-US" sz="650" b="1" dirty="0">
-                <a:solidFill>
-                  <a:srgbClr val="FFFFFF"/>
-                </a:solidFill>
-                <a:latin typeface="Arial" pitchFamily="34" charset="0"/>
-                <a:ea typeface="Arial" pitchFamily="34" charset="-122"/>
-                <a:cs typeface="Arial" pitchFamily="34" charset="-120"/>
-              </a:rPr>
-              <a:t>حدث رقم 7</a:t>
-            </a:r>
-            <a:endParaRPr lang="ar-SA" sz="650" dirty="0"/>
-          </a:p>
-        </p:txBody>
-      </p:sp>
-      <p:sp>
-        <p:nvSpPr>
-          <p:cNvPr id="91" name="Text 89"/>
-          <p:cNvSpPr/>
-          <p:nvPr/>
-        </p:nvSpPr>
-        <p:spPr>
-          <a:xfrm>
-            <a:off x="7290780" y="1581912"/>
-            <a:ext cx="1039189" cy="210312"/>
-          </a:xfrm>
-          <a:prstGeom prst="rect">
-            <a:avLst/>
-          </a:prstGeom>
-          <a:noFill/>
-          <a:ln/>
-        </p:spPr>
-        <p:txBody>
-          <a:bodyPr wrap="square" lIns="0" tIns="0" rIns="0" bIns="0" rtlCol="0" anchor="ctr">
-            <a:normAutofit/>
-          </a:bodyPr>
-          <a:lstStyle/>
-          <a:p>
             <a:pPr rtl="1" algn="r" indent="0" marL="0">
               <a:buNone/>
             </a:pPr>
             <a:r>
-              <a:rPr lang="ar-SA" altLang="en-US" sz="900" b="1" dirty="0">
+              <a:rPr lang="ar-SA" altLang="en-US" sz="950" b="1" dirty="0">
                 <a:solidFill>
                   <a:srgbClr val="3D3935"/>
                 </a:solidFill>
@@ -4342,20 +3746,20 @@
               </a:rPr>
               <a:t>أربعاء 7 أكتوبر 2026</a:t>
             </a:r>
-            <a:endParaRPr lang="ar-SA" sz="900" dirty="0"/>
-          </a:p>
-        </p:txBody>
-      </p:sp>
-      <p:sp>
-        <p:nvSpPr>
-          <p:cNvPr id="92" name="Text 90"/>
-          <p:cNvSpPr/>
-          <p:nvPr/>
-        </p:nvSpPr>
-        <p:spPr>
-          <a:xfrm>
-            <a:off x="6495252" y="1828800"/>
-            <a:ext cx="1834717" cy="539496"/>
+            <a:endParaRPr lang="ar-SA" sz="950" dirty="0"/>
+          </a:p>
+        </p:txBody>
+      </p:sp>
+      <p:sp>
+        <p:nvSpPr>
+          <p:cNvPr id="78" name="Text 76"/>
+          <p:cNvSpPr/>
+          <p:nvPr/>
+        </p:nvSpPr>
+        <p:spPr>
+          <a:xfrm>
+            <a:off x="6495252" y="2231136"/>
+            <a:ext cx="1834717" cy="338328"/>
           </a:xfrm>
           <a:prstGeom prst="rect">
             <a:avLst/>
@@ -4408,38 +3812,18 @@
             </a:r>
             <a:endParaRPr lang="ar-SA" sz="650" dirty="0"/>
           </a:p>
-          <a:p>
-            <a:pPr algn="r" indent="0" marL="0">
-              <a:spcAft>
-                <a:spcPts val="100"/>
-              </a:spcAft>
-              <a:buNone/>
-            </a:pPr>
-            <a:r>
-              <a:rPr lang="ar-SA" altLang="en-US" sz="700" dirty="0">
-                <a:solidFill>
-                  <a:srgbClr val="444D55"/>
-                </a:solidFill>
-                <a:latin typeface="Arial" pitchFamily="34" charset="0"/>
-                <a:ea typeface="Arial" pitchFamily="34" charset="-122"/>
-                <a:cs typeface="Arial" pitchFamily="34" charset="-120"/>
-              </a:rPr>
-              <a:t>بيان طريقة العمل وخطة العمل التفصيلية لجميع الإدارات للمراجعة والاعتماد.</a:t>
-            </a:r>
-            <a:endParaRPr lang="ar-SA" sz="650" dirty="0"/>
-          </a:p>
-        </p:txBody>
-      </p:sp>
-      <p:sp>
-        <p:nvSpPr>
-          <p:cNvPr id="93" name="Shape 91"/>
+        </p:txBody>
+      </p:sp>
+      <p:sp>
+        <p:nvSpPr>
+          <p:cNvPr id="79" name="Shape 77"/>
           <p:cNvSpPr/>
           <p:nvPr/>
         </p:nvSpPr>
         <p:spPr>
           <a:xfrm>
             <a:off x="6761773" y="4050792"/>
-            <a:ext cx="0" cy="1207008"/>
+            <a:ext cx="0" cy="1005840"/>
           </a:xfrm>
           <a:prstGeom prst="line">
             <a:avLst/>
@@ -4457,7 +3841,7 @@
       </p:sp>
       <p:sp>
         <p:nvSpPr>
-          <p:cNvPr id="94" name="Shape 92"/>
+          <p:cNvPr id="80" name="Shape 78"/>
           <p:cNvSpPr/>
           <p:nvPr/>
         </p:nvSpPr>
@@ -4489,7 +3873,7 @@
       </p:sp>
       <p:sp>
         <p:nvSpPr>
-          <p:cNvPr id="95" name="Text 93"/>
+          <p:cNvPr id="81" name="Text 79"/>
           <p:cNvSpPr/>
           <p:nvPr/>
         </p:nvSpPr>
@@ -4530,18 +3914,18 @@
       </p:sp>
       <p:sp>
         <p:nvSpPr>
-          <p:cNvPr id="96" name="Shape 94"/>
-          <p:cNvSpPr/>
-          <p:nvPr/>
-        </p:nvSpPr>
-        <p:spPr>
-          <a:xfrm>
-            <a:off x="5752974" y="5257800"/>
-            <a:ext cx="2017597" cy="914400"/>
+          <p:cNvPr id="82" name="Shape 80"/>
+          <p:cNvSpPr/>
+          <p:nvPr/>
+        </p:nvSpPr>
+        <p:spPr>
+          <a:xfrm>
+            <a:off x="5752974" y="5056632"/>
+            <a:ext cx="2017597" cy="713232"/>
           </a:xfrm>
           <a:prstGeom prst="roundRect">
             <a:avLst>
-              <a:gd name="adj" fmla="val 8000"/>
+              <a:gd name="adj" fmla="val 10256"/>
             </a:avLst>
           </a:prstGeom>
           <a:solidFill>
@@ -4564,13 +3948,13 @@
       </p:sp>
       <p:sp>
         <p:nvSpPr>
-          <p:cNvPr id="97" name="Shape 95"/>
-          <p:cNvSpPr/>
-          <p:nvPr/>
-        </p:nvSpPr>
-        <p:spPr>
-          <a:xfrm>
-            <a:off x="5826126" y="5257800"/>
+          <p:cNvPr id="83" name="Shape 81"/>
+          <p:cNvSpPr/>
+          <p:nvPr/>
+        </p:nvSpPr>
+        <p:spPr>
+          <a:xfrm>
+            <a:off x="5826126" y="5056632"/>
             <a:ext cx="1871293" cy="54864"/>
           </a:xfrm>
           <a:prstGeom prst="rect">
@@ -4589,41 +3973,14 @@
       </p:sp>
       <p:sp>
         <p:nvSpPr>
-          <p:cNvPr id="98" name="Shape 96"/>
-          <p:cNvSpPr/>
-          <p:nvPr/>
-        </p:nvSpPr>
-        <p:spPr>
-          <a:xfrm>
-            <a:off x="5844414" y="5349240"/>
-            <a:ext cx="749808" cy="173736"/>
-          </a:xfrm>
-          <a:prstGeom prst="roundRect">
-            <a:avLst>
-              <a:gd name="adj" fmla="val 50000"/>
-            </a:avLst>
-          </a:prstGeom>
-          <a:solidFill>
-            <a:srgbClr val="00778B"/>
-          </a:solidFill>
-          <a:ln w="12700">
-            <a:solidFill>
-              <a:srgbClr val="00778B"/>
-            </a:solidFill>
-            <a:prstDash val="solid"/>
-          </a:ln>
-        </p:spPr>
-      </p:sp>
-      <p:sp>
-        <p:nvSpPr>
-          <p:cNvPr id="99" name="Text 97"/>
-          <p:cNvSpPr/>
-          <p:nvPr/>
-        </p:nvSpPr>
-        <p:spPr>
-          <a:xfrm>
-            <a:off x="5844414" y="5349240"/>
-            <a:ext cx="749808" cy="173736"/>
+          <p:cNvPr id="84" name="Text 82"/>
+          <p:cNvSpPr/>
+          <p:nvPr/>
+        </p:nvSpPr>
+        <p:spPr>
+          <a:xfrm>
+            <a:off x="5844414" y="5129784"/>
+            <a:ext cx="1834717" cy="210312"/>
           </a:xfrm>
           <a:prstGeom prst="rect">
             <a:avLst/>
@@ -4637,52 +3994,11 @@
           </a:bodyPr>
           <a:lstStyle/>
           <a:p>
-            <a:pPr rtl="1" algn="ctr" indent="0" marL="0">
-              <a:buNone/>
-            </a:pPr>
-            <a:r>
-              <a:rPr lang="ar-SA" altLang="en-US" sz="650" b="1" dirty="0">
-                <a:solidFill>
-                  <a:srgbClr val="FFFFFF"/>
-                </a:solidFill>
-                <a:latin typeface="Arial" pitchFamily="34" charset="0"/>
-                <a:ea typeface="Arial" pitchFamily="34" charset="-122"/>
-                <a:cs typeface="Arial" pitchFamily="34" charset="-120"/>
-              </a:rPr>
-              <a:t>حدث رقم 8</a:t>
-            </a:r>
-            <a:endParaRPr lang="ar-SA" sz="650" dirty="0"/>
-          </a:p>
-        </p:txBody>
-      </p:sp>
-      <p:sp>
-        <p:nvSpPr>
-          <p:cNvPr id="100" name="Text 98"/>
-          <p:cNvSpPr/>
-          <p:nvPr/>
-        </p:nvSpPr>
-        <p:spPr>
-          <a:xfrm>
-            <a:off x="6639942" y="5330952"/>
-            <a:ext cx="1039189" cy="210312"/>
-          </a:xfrm>
-          <a:prstGeom prst="rect">
-            <a:avLst/>
-          </a:prstGeom>
-          <a:noFill/>
-          <a:ln/>
-        </p:spPr>
-        <p:txBody>
-          <a:bodyPr wrap="square" lIns="0" tIns="0" rIns="0" bIns="0" rtlCol="0" anchor="ctr">
-            <a:normAutofit/>
-          </a:bodyPr>
-          <a:lstStyle/>
-          <a:p>
             <a:pPr rtl="1" algn="r" indent="0" marL="0">
               <a:buNone/>
             </a:pPr>
             <a:r>
-              <a:rPr lang="ar-SA" altLang="en-US" sz="900" b="1" dirty="0">
+              <a:rPr lang="ar-SA" altLang="en-US" sz="950" b="1" dirty="0">
                 <a:solidFill>
                   <a:srgbClr val="3D3935"/>
                 </a:solidFill>
@@ -4692,20 +4008,20 @@
               </a:rPr>
               <a:t>أربعاء 7 أكتوبر 2026</a:t>
             </a:r>
-            <a:endParaRPr lang="ar-SA" sz="900" dirty="0"/>
-          </a:p>
-        </p:txBody>
-      </p:sp>
-      <p:sp>
-        <p:nvSpPr>
-          <p:cNvPr id="101" name="Text 99"/>
-          <p:cNvSpPr/>
-          <p:nvPr/>
-        </p:nvSpPr>
-        <p:spPr>
-          <a:xfrm>
-            <a:off x="5844414" y="5577840"/>
-            <a:ext cx="1834717" cy="539496"/>
+            <a:endParaRPr lang="ar-SA" sz="950" dirty="0"/>
+          </a:p>
+        </p:txBody>
+      </p:sp>
+      <p:sp>
+        <p:nvSpPr>
+          <p:cNvPr id="85" name="Text 83"/>
+          <p:cNvSpPr/>
+          <p:nvPr/>
+        </p:nvSpPr>
+        <p:spPr>
+          <a:xfrm>
+            <a:off x="5844414" y="5376672"/>
+            <a:ext cx="1834717" cy="338328"/>
           </a:xfrm>
           <a:prstGeom prst="rect">
             <a:avLst/>
@@ -4758,31 +4074,11 @@
             </a:r>
             <a:endParaRPr lang="ar-SA" sz="650" dirty="0"/>
           </a:p>
-          <a:p>
-            <a:pPr algn="r" indent="0" marL="0">
-              <a:spcAft>
-                <a:spcPts val="100"/>
-              </a:spcAft>
-              <a:buNone/>
-            </a:pPr>
-            <a:r>
-              <a:rPr lang="ar-SA" altLang="en-US" sz="700" dirty="0">
-                <a:solidFill>
-                  <a:srgbClr val="444D55"/>
-                </a:solidFill>
-                <a:latin typeface="Arial" pitchFamily="34" charset="0"/>
-                <a:ea typeface="Arial" pitchFamily="34" charset="-122"/>
-                <a:cs typeface="Arial" pitchFamily="34" charset="-120"/>
-              </a:rPr>
-              <a:t>الاتفاق على المضي قدماً وطلب مراجعة الإجراءات واعتمادها من الإدارات.</a:t>
-            </a:r>
-            <a:endParaRPr lang="ar-SA" sz="650" dirty="0"/>
-          </a:p>
-        </p:txBody>
-      </p:sp>
-      <p:sp>
-        <p:nvSpPr>
-          <p:cNvPr id="102" name="Shape 100"/>
+        </p:txBody>
+      </p:sp>
+      <p:sp>
+        <p:nvSpPr>
+          <p:cNvPr id="86" name="Shape 84"/>
           <p:cNvSpPr/>
           <p:nvPr/>
         </p:nvSpPr>
@@ -4807,7 +4103,7 @@
       </p:sp>
       <p:sp>
         <p:nvSpPr>
-          <p:cNvPr id="103" name="Shape 101"/>
+          <p:cNvPr id="87" name="Shape 85"/>
           <p:cNvSpPr/>
           <p:nvPr/>
         </p:nvSpPr>
@@ -4839,7 +4135,7 @@
       </p:sp>
       <p:sp>
         <p:nvSpPr>
-          <p:cNvPr id="104" name="Text 102"/>
+          <p:cNvPr id="88" name="Text 86"/>
           <p:cNvSpPr/>
           <p:nvPr/>
         </p:nvSpPr>
@@ -4880,18 +4176,18 @@
       </p:sp>
       <p:sp>
         <p:nvSpPr>
-          <p:cNvPr id="105" name="Shape 103"/>
-          <p:cNvSpPr/>
-          <p:nvPr/>
-        </p:nvSpPr>
-        <p:spPr>
-          <a:xfrm>
-            <a:off x="5102137" y="2532888"/>
-            <a:ext cx="2017597" cy="914400"/>
+          <p:cNvPr id="89" name="Shape 87"/>
+          <p:cNvSpPr/>
+          <p:nvPr/>
+        </p:nvSpPr>
+        <p:spPr>
+          <a:xfrm>
+            <a:off x="5102137" y="2734056"/>
+            <a:ext cx="2017597" cy="713232"/>
           </a:xfrm>
           <a:prstGeom prst="roundRect">
             <a:avLst>
-              <a:gd name="adj" fmla="val 8000"/>
+              <a:gd name="adj" fmla="val 10256"/>
             </a:avLst>
           </a:prstGeom>
           <a:solidFill>
@@ -4914,13 +4210,13 @@
       </p:sp>
       <p:sp>
         <p:nvSpPr>
-          <p:cNvPr id="106" name="Shape 104"/>
-          <p:cNvSpPr/>
-          <p:nvPr/>
-        </p:nvSpPr>
-        <p:spPr>
-          <a:xfrm>
-            <a:off x="5175289" y="2532888"/>
+          <p:cNvPr id="90" name="Shape 88"/>
+          <p:cNvSpPr/>
+          <p:nvPr/>
+        </p:nvSpPr>
+        <p:spPr>
+          <a:xfrm>
+            <a:off x="5175289" y="2734056"/>
             <a:ext cx="1871293" cy="54864"/>
           </a:xfrm>
           <a:prstGeom prst="rect">
@@ -4939,41 +4235,14 @@
       </p:sp>
       <p:sp>
         <p:nvSpPr>
-          <p:cNvPr id="107" name="Shape 105"/>
-          <p:cNvSpPr/>
-          <p:nvPr/>
-        </p:nvSpPr>
-        <p:spPr>
-          <a:xfrm>
-            <a:off x="5193577" y="2624328"/>
-            <a:ext cx="749808" cy="173736"/>
-          </a:xfrm>
-          <a:prstGeom prst="roundRect">
-            <a:avLst>
-              <a:gd name="adj" fmla="val 50000"/>
-            </a:avLst>
-          </a:prstGeom>
-          <a:solidFill>
-            <a:srgbClr val="00778B"/>
-          </a:solidFill>
-          <a:ln w="12700">
-            <a:solidFill>
-              <a:srgbClr val="00778B"/>
-            </a:solidFill>
-            <a:prstDash val="solid"/>
-          </a:ln>
-        </p:spPr>
-      </p:sp>
-      <p:sp>
-        <p:nvSpPr>
-          <p:cNvPr id="108" name="Text 106"/>
-          <p:cNvSpPr/>
-          <p:nvPr/>
-        </p:nvSpPr>
-        <p:spPr>
-          <a:xfrm>
-            <a:off x="5193577" y="2624328"/>
-            <a:ext cx="749808" cy="173736"/>
+          <p:cNvPr id="91" name="Text 89"/>
+          <p:cNvSpPr/>
+          <p:nvPr/>
+        </p:nvSpPr>
+        <p:spPr>
+          <a:xfrm>
+            <a:off x="5193577" y="2807208"/>
+            <a:ext cx="1834717" cy="210312"/>
           </a:xfrm>
           <a:prstGeom prst="rect">
             <a:avLst/>
@@ -4987,52 +4256,11 @@
           </a:bodyPr>
           <a:lstStyle/>
           <a:p>
-            <a:pPr rtl="1" algn="ctr" indent="0" marL="0">
-              <a:buNone/>
-            </a:pPr>
-            <a:r>
-              <a:rPr lang="ar-SA" altLang="en-US" sz="650" b="1" dirty="0">
-                <a:solidFill>
-                  <a:srgbClr val="FFFFFF"/>
-                </a:solidFill>
-                <a:latin typeface="Arial" pitchFamily="34" charset="0"/>
-                <a:ea typeface="Arial" pitchFamily="34" charset="-122"/>
-                <a:cs typeface="Arial" pitchFamily="34" charset="-120"/>
-              </a:rPr>
-              <a:t>حدث رقم 9</a:t>
-            </a:r>
-            <a:endParaRPr lang="ar-SA" sz="650" dirty="0"/>
-          </a:p>
-        </p:txBody>
-      </p:sp>
-      <p:sp>
-        <p:nvSpPr>
-          <p:cNvPr id="109" name="Text 107"/>
-          <p:cNvSpPr/>
-          <p:nvPr/>
-        </p:nvSpPr>
-        <p:spPr>
-          <a:xfrm>
-            <a:off x="5989105" y="2606040"/>
-            <a:ext cx="1039189" cy="210312"/>
-          </a:xfrm>
-          <a:prstGeom prst="rect">
-            <a:avLst/>
-          </a:prstGeom>
-          <a:noFill/>
-          <a:ln/>
-        </p:spPr>
-        <p:txBody>
-          <a:bodyPr wrap="square" lIns="0" tIns="0" rIns="0" bIns="0" rtlCol="0" anchor="ctr">
-            <a:normAutofit/>
-          </a:bodyPr>
-          <a:lstStyle/>
-          <a:p>
             <a:pPr rtl="1" algn="r" indent="0" marL="0">
               <a:buNone/>
             </a:pPr>
             <a:r>
-              <a:rPr lang="ar-SA" altLang="en-US" sz="900" b="1" dirty="0">
+              <a:rPr lang="ar-SA" altLang="en-US" sz="950" b="1" dirty="0">
                 <a:solidFill>
                   <a:srgbClr val="3D3935"/>
                 </a:solidFill>
@@ -5042,20 +4270,20 @@
               </a:rPr>
               <a:t>خميس 8 أكتوبر 2026</a:t>
             </a:r>
-            <a:endParaRPr lang="ar-SA" sz="900" dirty="0"/>
-          </a:p>
-        </p:txBody>
-      </p:sp>
-      <p:sp>
-        <p:nvSpPr>
-          <p:cNvPr id="110" name="Text 108"/>
-          <p:cNvSpPr/>
-          <p:nvPr/>
-        </p:nvSpPr>
-        <p:spPr>
-          <a:xfrm>
-            <a:off x="5193577" y="2852928"/>
-            <a:ext cx="1834717" cy="539496"/>
+            <a:endParaRPr lang="ar-SA" sz="950" dirty="0"/>
+          </a:p>
+        </p:txBody>
+      </p:sp>
+      <p:sp>
+        <p:nvSpPr>
+          <p:cNvPr id="92" name="Text 90"/>
+          <p:cNvSpPr/>
+          <p:nvPr/>
+        </p:nvSpPr>
+        <p:spPr>
+          <a:xfrm>
+            <a:off x="5193577" y="3054096"/>
+            <a:ext cx="1834717" cy="338328"/>
           </a:xfrm>
           <a:prstGeom prst="rect">
             <a:avLst/>
@@ -5108,31 +4336,11 @@
             </a:r>
             <a:endParaRPr lang="ar-SA" sz="650" dirty="0"/>
           </a:p>
-          <a:p>
-            <a:pPr algn="r" indent="0" marL="0">
-              <a:spcAft>
-                <a:spcPts val="100"/>
-              </a:spcAft>
-              <a:buNone/>
-            </a:pPr>
-            <a:r>
-              <a:rPr lang="ar-SA" altLang="en-US" sz="700" dirty="0">
-                <a:solidFill>
-                  <a:srgbClr val="444D55"/>
-                </a:solidFill>
-                <a:latin typeface="Arial" pitchFamily="34" charset="0"/>
-                <a:ea typeface="Arial" pitchFamily="34" charset="-122"/>
-                <a:cs typeface="Arial" pitchFamily="34" charset="-120"/>
-              </a:rPr>
-              <a:t>تم الرد على كل الاستفسارات بشأن الأعمال وإجراءات السلامة.</a:t>
-            </a:r>
-            <a:endParaRPr lang="ar-SA" sz="650" dirty="0"/>
-          </a:p>
-        </p:txBody>
-      </p:sp>
-      <p:sp>
-        <p:nvSpPr>
-          <p:cNvPr id="111" name="Shape 109"/>
+        </p:txBody>
+      </p:sp>
+      <p:sp>
+        <p:nvSpPr>
+          <p:cNvPr id="93" name="Shape 91"/>
           <p:cNvSpPr/>
           <p:nvPr/>
         </p:nvSpPr>
@@ -5157,7 +4365,7 @@
       </p:sp>
       <p:sp>
         <p:nvSpPr>
-          <p:cNvPr id="112" name="Shape 110"/>
+          <p:cNvPr id="94" name="Shape 92"/>
           <p:cNvSpPr/>
           <p:nvPr/>
         </p:nvSpPr>
@@ -5189,7 +4397,7 @@
       </p:sp>
       <p:sp>
         <p:nvSpPr>
-          <p:cNvPr id="113" name="Text 111"/>
+          <p:cNvPr id="95" name="Text 93"/>
           <p:cNvSpPr/>
           <p:nvPr/>
         </p:nvSpPr>
@@ -5230,18 +4438,18 @@
       </p:sp>
       <p:sp>
         <p:nvSpPr>
-          <p:cNvPr id="114" name="Shape 112"/>
+          <p:cNvPr id="96" name="Shape 94"/>
           <p:cNvSpPr/>
           <p:nvPr/>
         </p:nvSpPr>
         <p:spPr>
           <a:xfrm>
             <a:off x="4451299" y="4233672"/>
-            <a:ext cx="2017597" cy="914400"/>
+            <a:ext cx="2017597" cy="713232"/>
           </a:xfrm>
           <a:prstGeom prst="roundRect">
             <a:avLst>
-              <a:gd name="adj" fmla="val 8000"/>
+              <a:gd name="adj" fmla="val 10256"/>
             </a:avLst>
           </a:prstGeom>
           <a:solidFill>
@@ -5264,7 +4472,7 @@
       </p:sp>
       <p:sp>
         <p:nvSpPr>
-          <p:cNvPr id="115" name="Shape 113"/>
+          <p:cNvPr id="97" name="Shape 95"/>
           <p:cNvSpPr/>
           <p:nvPr/>
         </p:nvSpPr>
@@ -5289,41 +4497,14 @@
       </p:sp>
       <p:sp>
         <p:nvSpPr>
-          <p:cNvPr id="116" name="Shape 114"/>
-          <p:cNvSpPr/>
-          <p:nvPr/>
-        </p:nvSpPr>
-        <p:spPr>
-          <a:xfrm>
-            <a:off x="4542739" y="4325112"/>
-            <a:ext cx="749808" cy="173736"/>
-          </a:xfrm>
-          <a:prstGeom prst="roundRect">
-            <a:avLst>
-              <a:gd name="adj" fmla="val 50000"/>
-            </a:avLst>
-          </a:prstGeom>
-          <a:solidFill>
-            <a:srgbClr val="00778B"/>
-          </a:solidFill>
-          <a:ln w="12700">
-            <a:solidFill>
-              <a:srgbClr val="00778B"/>
-            </a:solidFill>
-            <a:prstDash val="solid"/>
-          </a:ln>
-        </p:spPr>
-      </p:sp>
-      <p:sp>
-        <p:nvSpPr>
-          <p:cNvPr id="117" name="Text 115"/>
-          <p:cNvSpPr/>
-          <p:nvPr/>
-        </p:nvSpPr>
-        <p:spPr>
-          <a:xfrm>
-            <a:off x="4542739" y="4325112"/>
-            <a:ext cx="749808" cy="173736"/>
+          <p:cNvPr id="98" name="Text 96"/>
+          <p:cNvSpPr/>
+          <p:nvPr/>
+        </p:nvSpPr>
+        <p:spPr>
+          <a:xfrm>
+            <a:off x="4542739" y="4306824"/>
+            <a:ext cx="1834717" cy="210312"/>
           </a:xfrm>
           <a:prstGeom prst="rect">
             <a:avLst/>
@@ -5337,52 +4518,11 @@
           </a:bodyPr>
           <a:lstStyle/>
           <a:p>
-            <a:pPr rtl="1" algn="ctr" indent="0" marL="0">
-              <a:buNone/>
-            </a:pPr>
-            <a:r>
-              <a:rPr lang="ar-SA" altLang="en-US" sz="650" b="1" dirty="0">
-                <a:solidFill>
-                  <a:srgbClr val="FFFFFF"/>
-                </a:solidFill>
-                <a:latin typeface="Arial" pitchFamily="34" charset="0"/>
-                <a:ea typeface="Arial" pitchFamily="34" charset="-122"/>
-                <a:cs typeface="Arial" pitchFamily="34" charset="-120"/>
-              </a:rPr>
-              <a:t>حدث رقم 10</a:t>
-            </a:r>
-            <a:endParaRPr lang="ar-SA" sz="650" dirty="0"/>
-          </a:p>
-        </p:txBody>
-      </p:sp>
-      <p:sp>
-        <p:nvSpPr>
-          <p:cNvPr id="118" name="Text 116"/>
-          <p:cNvSpPr/>
-          <p:nvPr/>
-        </p:nvSpPr>
-        <p:spPr>
-          <a:xfrm>
-            <a:off x="5338267" y="4306824"/>
-            <a:ext cx="1039189" cy="210312"/>
-          </a:xfrm>
-          <a:prstGeom prst="rect">
-            <a:avLst/>
-          </a:prstGeom>
-          <a:noFill/>
-          <a:ln/>
-        </p:spPr>
-        <p:txBody>
-          <a:bodyPr wrap="square" lIns="0" tIns="0" rIns="0" bIns="0" rtlCol="0" anchor="ctr">
-            <a:normAutofit/>
-          </a:bodyPr>
-          <a:lstStyle/>
-          <a:p>
             <a:pPr rtl="1" algn="r" indent="0" marL="0">
               <a:buNone/>
             </a:pPr>
             <a:r>
-              <a:rPr lang="ar-SA" altLang="en-US" sz="900" b="1" dirty="0">
+              <a:rPr lang="ar-SA" altLang="en-US" sz="950" b="1" dirty="0">
                 <a:solidFill>
                   <a:srgbClr val="3D3935"/>
                 </a:solidFill>
@@ -5392,20 +4532,20 @@
               </a:rPr>
               <a:t>أحد 11 أكتوبر 2026</a:t>
             </a:r>
-            <a:endParaRPr lang="ar-SA" sz="900" dirty="0"/>
-          </a:p>
-        </p:txBody>
-      </p:sp>
-      <p:sp>
-        <p:nvSpPr>
-          <p:cNvPr id="119" name="Text 117"/>
+            <a:endParaRPr lang="ar-SA" sz="950" dirty="0"/>
+          </a:p>
+        </p:txBody>
+      </p:sp>
+      <p:sp>
+        <p:nvSpPr>
+          <p:cNvPr id="99" name="Text 97"/>
           <p:cNvSpPr/>
           <p:nvPr/>
         </p:nvSpPr>
         <p:spPr>
           <a:xfrm>
             <a:off x="4542739" y="4553712"/>
-            <a:ext cx="1834717" cy="539496"/>
+            <a:ext cx="1834717" cy="338328"/>
           </a:xfrm>
           <a:prstGeom prst="rect">
             <a:avLst/>
@@ -5458,38 +4598,18 @@
             </a:r>
             <a:endParaRPr lang="ar-SA" sz="650" dirty="0"/>
           </a:p>
-          <a:p>
-            <a:pPr algn="r" indent="0" marL="0">
-              <a:spcAft>
-                <a:spcPts val="100"/>
-              </a:spcAft>
-              <a:buNone/>
-            </a:pPr>
-            <a:r>
-              <a:rPr lang="ar-SA" altLang="en-US" sz="700" dirty="0">
-                <a:solidFill>
-                  <a:srgbClr val="444D55"/>
-                </a:solidFill>
-                <a:latin typeface="Arial" pitchFamily="34" charset="0"/>
-                <a:ea typeface="Arial" pitchFamily="34" charset="-122"/>
-                <a:cs typeface="Arial" pitchFamily="34" charset="-120"/>
-              </a:rPr>
-              <a:t>أثارت إدارة الهندسة استيضاحاً على بيان طريقة العمل.</a:t>
-            </a:r>
-            <a:endParaRPr lang="ar-SA" sz="650" dirty="0"/>
-          </a:p>
-        </p:txBody>
-      </p:sp>
-      <p:sp>
-        <p:nvSpPr>
-          <p:cNvPr id="120" name="Shape 118"/>
-          <p:cNvSpPr/>
-          <p:nvPr/>
-        </p:nvSpPr>
-        <p:spPr>
-          <a:xfrm>
-            <a:off x="4809260" y="2423160"/>
-            <a:ext cx="0" cy="1207008"/>
+        </p:txBody>
+      </p:sp>
+      <p:sp>
+        <p:nvSpPr>
+          <p:cNvPr id="100" name="Shape 98"/>
+          <p:cNvSpPr/>
+          <p:nvPr/>
+        </p:nvSpPr>
+        <p:spPr>
+          <a:xfrm>
+            <a:off x="4809260" y="2624328"/>
+            <a:ext cx="0" cy="1005840"/>
           </a:xfrm>
           <a:prstGeom prst="line">
             <a:avLst/>
@@ -5507,7 +4627,7 @@
       </p:sp>
       <p:sp>
         <p:nvSpPr>
-          <p:cNvPr id="121" name="Shape 119"/>
+          <p:cNvPr id="101" name="Shape 99"/>
           <p:cNvSpPr/>
           <p:nvPr/>
         </p:nvSpPr>
@@ -5539,7 +4659,7 @@
       </p:sp>
       <p:sp>
         <p:nvSpPr>
-          <p:cNvPr id="122" name="Text 120"/>
+          <p:cNvPr id="102" name="Text 100"/>
           <p:cNvSpPr/>
           <p:nvPr/>
         </p:nvSpPr>
@@ -5580,18 +4700,18 @@
       </p:sp>
       <p:sp>
         <p:nvSpPr>
-          <p:cNvPr id="123" name="Shape 121"/>
-          <p:cNvSpPr/>
-          <p:nvPr/>
-        </p:nvSpPr>
-        <p:spPr>
-          <a:xfrm>
-            <a:off x="3800462" y="1508760"/>
-            <a:ext cx="2017597" cy="914400"/>
+          <p:cNvPr id="103" name="Shape 101"/>
+          <p:cNvSpPr/>
+          <p:nvPr/>
+        </p:nvSpPr>
+        <p:spPr>
+          <a:xfrm>
+            <a:off x="3800462" y="1911096"/>
+            <a:ext cx="2017597" cy="713232"/>
           </a:xfrm>
           <a:prstGeom prst="roundRect">
             <a:avLst>
-              <a:gd name="adj" fmla="val 8000"/>
+              <a:gd name="adj" fmla="val 10256"/>
             </a:avLst>
           </a:prstGeom>
           <a:solidFill>
@@ -5614,13 +4734,13 @@
       </p:sp>
       <p:sp>
         <p:nvSpPr>
-          <p:cNvPr id="124" name="Shape 122"/>
-          <p:cNvSpPr/>
-          <p:nvPr/>
-        </p:nvSpPr>
-        <p:spPr>
-          <a:xfrm>
-            <a:off x="3873614" y="1508760"/>
+          <p:cNvPr id="104" name="Shape 102"/>
+          <p:cNvSpPr/>
+          <p:nvPr/>
+        </p:nvSpPr>
+        <p:spPr>
+          <a:xfrm>
+            <a:off x="3873614" y="1911096"/>
             <a:ext cx="1871293" cy="54864"/>
           </a:xfrm>
           <a:prstGeom prst="rect">
@@ -5639,41 +4759,14 @@
       </p:sp>
       <p:sp>
         <p:nvSpPr>
-          <p:cNvPr id="125" name="Shape 123"/>
-          <p:cNvSpPr/>
-          <p:nvPr/>
-        </p:nvSpPr>
-        <p:spPr>
-          <a:xfrm>
-            <a:off x="3891902" y="1600200"/>
-            <a:ext cx="749808" cy="173736"/>
-          </a:xfrm>
-          <a:prstGeom prst="roundRect">
-            <a:avLst>
-              <a:gd name="adj" fmla="val 50000"/>
-            </a:avLst>
-          </a:prstGeom>
-          <a:solidFill>
-            <a:srgbClr val="00778B"/>
-          </a:solidFill>
-          <a:ln w="12700">
-            <a:solidFill>
-              <a:srgbClr val="00778B"/>
-            </a:solidFill>
-            <a:prstDash val="solid"/>
-          </a:ln>
-        </p:spPr>
-      </p:sp>
-      <p:sp>
-        <p:nvSpPr>
-          <p:cNvPr id="126" name="Text 124"/>
-          <p:cNvSpPr/>
-          <p:nvPr/>
-        </p:nvSpPr>
-        <p:spPr>
-          <a:xfrm>
-            <a:off x="3891902" y="1600200"/>
-            <a:ext cx="749808" cy="173736"/>
+          <p:cNvPr id="105" name="Text 103"/>
+          <p:cNvSpPr/>
+          <p:nvPr/>
+        </p:nvSpPr>
+        <p:spPr>
+          <a:xfrm>
+            <a:off x="3891902" y="1984248"/>
+            <a:ext cx="1834717" cy="210312"/>
           </a:xfrm>
           <a:prstGeom prst="rect">
             <a:avLst/>
@@ -5687,52 +4780,11 @@
           </a:bodyPr>
           <a:lstStyle/>
           <a:p>
-            <a:pPr rtl="1" algn="ctr" indent="0" marL="0">
-              <a:buNone/>
-            </a:pPr>
-            <a:r>
-              <a:rPr lang="ar-SA" altLang="en-US" sz="650" b="1" dirty="0">
-                <a:solidFill>
-                  <a:srgbClr val="FFFFFF"/>
-                </a:solidFill>
-                <a:latin typeface="Arial" pitchFamily="34" charset="0"/>
-                <a:ea typeface="Arial" pitchFamily="34" charset="-122"/>
-                <a:cs typeface="Arial" pitchFamily="34" charset="-120"/>
-              </a:rPr>
-              <a:t>حدث رقم 11</a:t>
-            </a:r>
-            <a:endParaRPr lang="ar-SA" sz="650" dirty="0"/>
-          </a:p>
-        </p:txBody>
-      </p:sp>
-      <p:sp>
-        <p:nvSpPr>
-          <p:cNvPr id="127" name="Text 125"/>
-          <p:cNvSpPr/>
-          <p:nvPr/>
-        </p:nvSpPr>
-        <p:spPr>
-          <a:xfrm>
-            <a:off x="4687430" y="1581912"/>
-            <a:ext cx="1039189" cy="210312"/>
-          </a:xfrm>
-          <a:prstGeom prst="rect">
-            <a:avLst/>
-          </a:prstGeom>
-          <a:noFill/>
-          <a:ln/>
-        </p:spPr>
-        <p:txBody>
-          <a:bodyPr wrap="square" lIns="0" tIns="0" rIns="0" bIns="0" rtlCol="0" anchor="ctr">
-            <a:normAutofit/>
-          </a:bodyPr>
-          <a:lstStyle/>
-          <a:p>
             <a:pPr rtl="1" algn="r" indent="0" marL="0">
               <a:buNone/>
             </a:pPr>
             <a:r>
-              <a:rPr lang="ar-SA" altLang="en-US" sz="900" b="1" dirty="0">
+              <a:rPr lang="ar-SA" altLang="en-US" sz="950" b="1" dirty="0">
                 <a:solidFill>
                   <a:srgbClr val="3D3935"/>
                 </a:solidFill>
@@ -5742,20 +4794,20 @@
               </a:rPr>
               <a:t>اثنين 12 أكتوبر 2026</a:t>
             </a:r>
-            <a:endParaRPr lang="ar-SA" sz="900" dirty="0"/>
-          </a:p>
-        </p:txBody>
-      </p:sp>
-      <p:sp>
-        <p:nvSpPr>
-          <p:cNvPr id="128" name="Text 126"/>
-          <p:cNvSpPr/>
-          <p:nvPr/>
-        </p:nvSpPr>
-        <p:spPr>
-          <a:xfrm>
-            <a:off x="3891902" y="1828800"/>
-            <a:ext cx="1834717" cy="539496"/>
+            <a:endParaRPr lang="ar-SA" sz="950" dirty="0"/>
+          </a:p>
+        </p:txBody>
+      </p:sp>
+      <p:sp>
+        <p:nvSpPr>
+          <p:cNvPr id="106" name="Text 104"/>
+          <p:cNvSpPr/>
+          <p:nvPr/>
+        </p:nvSpPr>
+        <p:spPr>
+          <a:xfrm>
+            <a:off x="3891902" y="2231136"/>
+            <a:ext cx="1834717" cy="338328"/>
           </a:xfrm>
           <a:prstGeom prst="rect">
             <a:avLst/>
@@ -5808,38 +4860,18 @@
             </a:r>
             <a:endParaRPr lang="ar-SA" sz="650" dirty="0"/>
           </a:p>
-          <a:p>
-            <a:pPr algn="r" indent="0" marL="0">
-              <a:spcAft>
-                <a:spcPts val="100"/>
-              </a:spcAft>
-              <a:buNone/>
-            </a:pPr>
-            <a:r>
-              <a:rPr lang="ar-SA" altLang="en-US" sz="700" dirty="0">
-                <a:solidFill>
-                  <a:srgbClr val="444D55"/>
-                </a:solidFill>
-                <a:latin typeface="Arial" pitchFamily="34" charset="0"/>
-                <a:ea typeface="Arial" pitchFamily="34" charset="-122"/>
-                <a:cs typeface="Arial" pitchFamily="34" charset="-120"/>
-              </a:rPr>
-              <a:t>قُدّمت المراجعة الثانية للبيان إلى جميع الإدارات المعنية.</a:t>
-            </a:r>
-            <a:endParaRPr lang="ar-SA" sz="650" dirty="0"/>
-          </a:p>
-        </p:txBody>
-      </p:sp>
-      <p:sp>
-        <p:nvSpPr>
-          <p:cNvPr id="129" name="Shape 127"/>
+        </p:txBody>
+      </p:sp>
+      <p:sp>
+        <p:nvSpPr>
+          <p:cNvPr id="107" name="Shape 105"/>
           <p:cNvSpPr/>
           <p:nvPr/>
         </p:nvSpPr>
         <p:spPr>
           <a:xfrm>
             <a:off x="4158422" y="4050792"/>
-            <a:ext cx="0" cy="1207008"/>
+            <a:ext cx="0" cy="1005840"/>
           </a:xfrm>
           <a:prstGeom prst="line">
             <a:avLst/>
@@ -5857,7 +4889,7 @@
       </p:sp>
       <p:sp>
         <p:nvSpPr>
-          <p:cNvPr id="130" name="Shape 128"/>
+          <p:cNvPr id="108" name="Shape 106"/>
           <p:cNvSpPr/>
           <p:nvPr/>
         </p:nvSpPr>
@@ -5889,7 +4921,7 @@
       </p:sp>
       <p:sp>
         <p:nvSpPr>
-          <p:cNvPr id="131" name="Text 129"/>
+          <p:cNvPr id="109" name="Text 107"/>
           <p:cNvSpPr/>
           <p:nvPr/>
         </p:nvSpPr>
@@ -5930,18 +4962,18 @@
       </p:sp>
       <p:sp>
         <p:nvSpPr>
-          <p:cNvPr id="132" name="Shape 130"/>
-          <p:cNvSpPr/>
-          <p:nvPr/>
-        </p:nvSpPr>
-        <p:spPr>
-          <a:xfrm>
-            <a:off x="3149624" y="5257800"/>
-            <a:ext cx="2017597" cy="914400"/>
+          <p:cNvPr id="110" name="Shape 108"/>
+          <p:cNvSpPr/>
+          <p:nvPr/>
+        </p:nvSpPr>
+        <p:spPr>
+          <a:xfrm>
+            <a:off x="3149624" y="5056632"/>
+            <a:ext cx="2017597" cy="713232"/>
           </a:xfrm>
           <a:prstGeom prst="roundRect">
             <a:avLst>
-              <a:gd name="adj" fmla="val 8000"/>
+              <a:gd name="adj" fmla="val 10256"/>
             </a:avLst>
           </a:prstGeom>
           <a:solidFill>
@@ -5964,13 +4996,13 @@
       </p:sp>
       <p:sp>
         <p:nvSpPr>
-          <p:cNvPr id="133" name="Shape 131"/>
-          <p:cNvSpPr/>
-          <p:nvPr/>
-        </p:nvSpPr>
-        <p:spPr>
-          <a:xfrm>
-            <a:off x="3222776" y="5257800"/>
+          <p:cNvPr id="111" name="Shape 109"/>
+          <p:cNvSpPr/>
+          <p:nvPr/>
+        </p:nvSpPr>
+        <p:spPr>
+          <a:xfrm>
+            <a:off x="3222776" y="5056632"/>
             <a:ext cx="1871293" cy="54864"/>
           </a:xfrm>
           <a:prstGeom prst="rect">
@@ -5989,41 +5021,14 @@
       </p:sp>
       <p:sp>
         <p:nvSpPr>
-          <p:cNvPr id="134" name="Shape 132"/>
-          <p:cNvSpPr/>
-          <p:nvPr/>
-        </p:nvSpPr>
-        <p:spPr>
-          <a:xfrm>
-            <a:off x="3241064" y="5349240"/>
-            <a:ext cx="749808" cy="173736"/>
-          </a:xfrm>
-          <a:prstGeom prst="roundRect">
-            <a:avLst>
-              <a:gd name="adj" fmla="val 50000"/>
-            </a:avLst>
-          </a:prstGeom>
-          <a:solidFill>
-            <a:srgbClr val="2E9E6B"/>
-          </a:solidFill>
-          <a:ln w="12700">
-            <a:solidFill>
-              <a:srgbClr val="2E9E6B"/>
-            </a:solidFill>
-            <a:prstDash val="solid"/>
-          </a:ln>
-        </p:spPr>
-      </p:sp>
-      <p:sp>
-        <p:nvSpPr>
-          <p:cNvPr id="135" name="Text 133"/>
-          <p:cNvSpPr/>
-          <p:nvPr/>
-        </p:nvSpPr>
-        <p:spPr>
-          <a:xfrm>
-            <a:off x="3241064" y="5349240"/>
-            <a:ext cx="749808" cy="173736"/>
+          <p:cNvPr id="112" name="Text 110"/>
+          <p:cNvSpPr/>
+          <p:nvPr/>
+        </p:nvSpPr>
+        <p:spPr>
+          <a:xfrm>
+            <a:off x="3241064" y="5129784"/>
+            <a:ext cx="1834717" cy="210312"/>
           </a:xfrm>
           <a:prstGeom prst="rect">
             <a:avLst/>
@@ -6037,52 +5042,11 @@
           </a:bodyPr>
           <a:lstStyle/>
           <a:p>
-            <a:pPr rtl="1" algn="ctr" indent="0" marL="0">
-              <a:buNone/>
-            </a:pPr>
-            <a:r>
-              <a:rPr lang="ar-SA" altLang="en-US" sz="650" b="1" dirty="0">
-                <a:solidFill>
-                  <a:srgbClr val="FFFFFF"/>
-                </a:solidFill>
-                <a:latin typeface="Arial" pitchFamily="34" charset="0"/>
-                <a:ea typeface="Arial" pitchFamily="34" charset="-122"/>
-                <a:cs typeface="Arial" pitchFamily="34" charset="-120"/>
-              </a:rPr>
-              <a:t>حدث رقم 12</a:t>
-            </a:r>
-            <a:endParaRPr lang="ar-SA" sz="650" dirty="0"/>
-          </a:p>
-        </p:txBody>
-      </p:sp>
-      <p:sp>
-        <p:nvSpPr>
-          <p:cNvPr id="136" name="Text 134"/>
-          <p:cNvSpPr/>
-          <p:nvPr/>
-        </p:nvSpPr>
-        <p:spPr>
-          <a:xfrm>
-            <a:off x="4036592" y="5330952"/>
-            <a:ext cx="1039189" cy="210312"/>
-          </a:xfrm>
-          <a:prstGeom prst="rect">
-            <a:avLst/>
-          </a:prstGeom>
-          <a:noFill/>
-          <a:ln/>
-        </p:spPr>
-        <p:txBody>
-          <a:bodyPr wrap="square" lIns="0" tIns="0" rIns="0" bIns="0" rtlCol="0" anchor="ctr">
-            <a:normAutofit/>
-          </a:bodyPr>
-          <a:lstStyle/>
-          <a:p>
             <a:pPr rtl="1" algn="r" indent="0" marL="0">
               <a:buNone/>
             </a:pPr>
             <a:r>
-              <a:rPr lang="ar-SA" altLang="en-US" sz="900" b="1" dirty="0">
+              <a:rPr lang="ar-SA" altLang="en-US" sz="950" b="1" dirty="0">
                 <a:solidFill>
                   <a:srgbClr val="3D3935"/>
                 </a:solidFill>
@@ -6092,20 +5056,20 @@
               </a:rPr>
               <a:t>ثلاثاء 13 أكتوبر 2026</a:t>
             </a:r>
-            <a:endParaRPr lang="ar-SA" sz="900" dirty="0"/>
-          </a:p>
-        </p:txBody>
-      </p:sp>
-      <p:sp>
-        <p:nvSpPr>
-          <p:cNvPr id="137" name="Text 135"/>
-          <p:cNvSpPr/>
-          <p:nvPr/>
-        </p:nvSpPr>
-        <p:spPr>
-          <a:xfrm>
-            <a:off x="3241064" y="5577840"/>
-            <a:ext cx="1834717" cy="539496"/>
+            <a:endParaRPr lang="ar-SA" sz="950" dirty="0"/>
+          </a:p>
+        </p:txBody>
+      </p:sp>
+      <p:sp>
+        <p:nvSpPr>
+          <p:cNvPr id="113" name="Text 111"/>
+          <p:cNvSpPr/>
+          <p:nvPr/>
+        </p:nvSpPr>
+        <p:spPr>
+          <a:xfrm>
+            <a:off x="3241064" y="5376672"/>
+            <a:ext cx="1834717" cy="338328"/>
           </a:xfrm>
           <a:prstGeom prst="rect">
             <a:avLst/>
@@ -6158,31 +5122,11 @@
             </a:r>
             <a:endParaRPr lang="ar-SA" sz="650" dirty="0"/>
           </a:p>
-          <a:p>
-            <a:pPr algn="r" indent="0" marL="0">
-              <a:spcAft>
-                <a:spcPts val="100"/>
-              </a:spcAft>
-              <a:buNone/>
-            </a:pPr>
-            <a:r>
-              <a:rPr lang="ar-SA" altLang="en-US" sz="700" dirty="0">
-                <a:solidFill>
-                  <a:srgbClr val="444D55"/>
-                </a:solidFill>
-                <a:latin typeface="Arial" pitchFamily="34" charset="0"/>
-                <a:ea typeface="Arial" pitchFamily="34" charset="-122"/>
-                <a:cs typeface="Arial" pitchFamily="34" charset="-120"/>
-              </a:rPr>
-              <a:t>بعد مشاركة المستندات تم التواصل مع السلامة لتسهيل إصدار التصريح.</a:t>
-            </a:r>
-            <a:endParaRPr lang="ar-SA" sz="650" dirty="0"/>
-          </a:p>
-        </p:txBody>
-      </p:sp>
-      <p:sp>
-        <p:nvSpPr>
-          <p:cNvPr id="138" name="Shape 136"/>
+        </p:txBody>
+      </p:sp>
+      <p:sp>
+        <p:nvSpPr>
+          <p:cNvPr id="114" name="Shape 112"/>
           <p:cNvSpPr/>
           <p:nvPr/>
         </p:nvSpPr>
@@ -6207,7 +5151,7 @@
       </p:sp>
       <p:sp>
         <p:nvSpPr>
-          <p:cNvPr id="139" name="Shape 137"/>
+          <p:cNvPr id="115" name="Shape 113"/>
           <p:cNvSpPr/>
           <p:nvPr/>
         </p:nvSpPr>
@@ -6239,7 +5183,7 @@
       </p:sp>
       <p:sp>
         <p:nvSpPr>
-          <p:cNvPr id="140" name="Text 138"/>
+          <p:cNvPr id="116" name="Text 114"/>
           <p:cNvSpPr/>
           <p:nvPr/>
         </p:nvSpPr>
@@ -6280,18 +5224,18 @@
       </p:sp>
       <p:sp>
         <p:nvSpPr>
-          <p:cNvPr id="141" name="Shape 139"/>
-          <p:cNvSpPr/>
-          <p:nvPr/>
-        </p:nvSpPr>
-        <p:spPr>
-          <a:xfrm>
-            <a:off x="2498786" y="2532888"/>
-            <a:ext cx="2017597" cy="914400"/>
+          <p:cNvPr id="117" name="Shape 115"/>
+          <p:cNvSpPr/>
+          <p:nvPr/>
+        </p:nvSpPr>
+        <p:spPr>
+          <a:xfrm>
+            <a:off x="2498786" y="2734056"/>
+            <a:ext cx="2017597" cy="713232"/>
           </a:xfrm>
           <a:prstGeom prst="roundRect">
             <a:avLst>
-              <a:gd name="adj" fmla="val 8000"/>
+              <a:gd name="adj" fmla="val 10256"/>
             </a:avLst>
           </a:prstGeom>
           <a:solidFill>
@@ -6314,13 +5258,13 @@
       </p:sp>
       <p:sp>
         <p:nvSpPr>
-          <p:cNvPr id="142" name="Shape 140"/>
-          <p:cNvSpPr/>
-          <p:nvPr/>
-        </p:nvSpPr>
-        <p:spPr>
-          <a:xfrm>
-            <a:off x="2571938" y="2532888"/>
+          <p:cNvPr id="118" name="Shape 116"/>
+          <p:cNvSpPr/>
+          <p:nvPr/>
+        </p:nvSpPr>
+        <p:spPr>
+          <a:xfrm>
+            <a:off x="2571938" y="2734056"/>
             <a:ext cx="1871293" cy="54864"/>
           </a:xfrm>
           <a:prstGeom prst="rect">
@@ -6339,41 +5283,14 @@
       </p:sp>
       <p:sp>
         <p:nvSpPr>
-          <p:cNvPr id="143" name="Shape 141"/>
-          <p:cNvSpPr/>
-          <p:nvPr/>
-        </p:nvSpPr>
-        <p:spPr>
-          <a:xfrm>
-            <a:off x="2590226" y="2624328"/>
-            <a:ext cx="749808" cy="173736"/>
-          </a:xfrm>
-          <a:prstGeom prst="roundRect">
-            <a:avLst>
-              <a:gd name="adj" fmla="val 50000"/>
-            </a:avLst>
-          </a:prstGeom>
-          <a:solidFill>
-            <a:srgbClr val="2E9E6B"/>
-          </a:solidFill>
-          <a:ln w="12700">
-            <a:solidFill>
-              <a:srgbClr val="2E9E6B"/>
-            </a:solidFill>
-            <a:prstDash val="solid"/>
-          </a:ln>
-        </p:spPr>
-      </p:sp>
-      <p:sp>
-        <p:nvSpPr>
-          <p:cNvPr id="144" name="Text 142"/>
-          <p:cNvSpPr/>
-          <p:nvPr/>
-        </p:nvSpPr>
-        <p:spPr>
-          <a:xfrm>
-            <a:off x="2590226" y="2624328"/>
-            <a:ext cx="749808" cy="173736"/>
+          <p:cNvPr id="119" name="Text 117"/>
+          <p:cNvSpPr/>
+          <p:nvPr/>
+        </p:nvSpPr>
+        <p:spPr>
+          <a:xfrm>
+            <a:off x="2590226" y="2807208"/>
+            <a:ext cx="1834717" cy="210312"/>
           </a:xfrm>
           <a:prstGeom prst="rect">
             <a:avLst/>
@@ -6387,52 +5304,11 @@
           </a:bodyPr>
           <a:lstStyle/>
           <a:p>
-            <a:pPr rtl="1" algn="ctr" indent="0" marL="0">
-              <a:buNone/>
-            </a:pPr>
-            <a:r>
-              <a:rPr lang="ar-SA" altLang="en-US" sz="650" b="1" dirty="0">
-                <a:solidFill>
-                  <a:srgbClr val="FFFFFF"/>
-                </a:solidFill>
-                <a:latin typeface="Arial" pitchFamily="34" charset="0"/>
-                <a:ea typeface="Arial" pitchFamily="34" charset="-122"/>
-                <a:cs typeface="Arial" pitchFamily="34" charset="-120"/>
-              </a:rPr>
-              <a:t>حدث رقم 13</a:t>
-            </a:r>
-            <a:endParaRPr lang="ar-SA" sz="650" dirty="0"/>
-          </a:p>
-        </p:txBody>
-      </p:sp>
-      <p:sp>
-        <p:nvSpPr>
-          <p:cNvPr id="145" name="Text 143"/>
-          <p:cNvSpPr/>
-          <p:nvPr/>
-        </p:nvSpPr>
-        <p:spPr>
-          <a:xfrm>
-            <a:off x="3385754" y="2606040"/>
-            <a:ext cx="1039189" cy="210312"/>
-          </a:xfrm>
-          <a:prstGeom prst="rect">
-            <a:avLst/>
-          </a:prstGeom>
-          <a:noFill/>
-          <a:ln/>
-        </p:spPr>
-        <p:txBody>
-          <a:bodyPr wrap="square" lIns="0" tIns="0" rIns="0" bIns="0" rtlCol="0" anchor="ctr">
-            <a:normAutofit/>
-          </a:bodyPr>
-          <a:lstStyle/>
-          <a:p>
             <a:pPr rtl="1" algn="r" indent="0" marL="0">
               <a:buNone/>
             </a:pPr>
             <a:r>
-              <a:rPr lang="ar-SA" altLang="en-US" sz="900" b="1" dirty="0">
+              <a:rPr lang="ar-SA" altLang="en-US" sz="950" b="1" dirty="0">
                 <a:solidFill>
                   <a:srgbClr val="3D3935"/>
                 </a:solidFill>
@@ -6442,20 +5318,20 @@
               </a:rPr>
               <a:t>أربعاء 14 أكتوبر 2026</a:t>
             </a:r>
-            <a:endParaRPr lang="ar-SA" sz="900" dirty="0"/>
-          </a:p>
-        </p:txBody>
-      </p:sp>
-      <p:sp>
-        <p:nvSpPr>
-          <p:cNvPr id="146" name="Text 144"/>
-          <p:cNvSpPr/>
-          <p:nvPr/>
-        </p:nvSpPr>
-        <p:spPr>
-          <a:xfrm>
-            <a:off x="2590226" y="2852928"/>
-            <a:ext cx="1834717" cy="539496"/>
+            <a:endParaRPr lang="ar-SA" sz="950" dirty="0"/>
+          </a:p>
+        </p:txBody>
+      </p:sp>
+      <p:sp>
+        <p:nvSpPr>
+          <p:cNvPr id="120" name="Text 118"/>
+          <p:cNvSpPr/>
+          <p:nvPr/>
+        </p:nvSpPr>
+        <p:spPr>
+          <a:xfrm>
+            <a:off x="2590226" y="3054096"/>
+            <a:ext cx="1834717" cy="338328"/>
           </a:xfrm>
           <a:prstGeom prst="rect">
             <a:avLst/>
@@ -6508,31 +5384,11 @@
             </a:r>
             <a:endParaRPr lang="ar-SA" sz="650" dirty="0"/>
           </a:p>
-          <a:p>
-            <a:pPr algn="r" indent="0" marL="0">
-              <a:spcAft>
-                <a:spcPts val="100"/>
-              </a:spcAft>
-              <a:buNone/>
-            </a:pPr>
-            <a:r>
-              <a:rPr lang="ar-SA" altLang="en-US" sz="700" dirty="0">
-                <a:solidFill>
-                  <a:srgbClr val="444D55"/>
-                </a:solidFill>
-                <a:latin typeface="Arial" pitchFamily="34" charset="0"/>
-                <a:ea typeface="Arial" pitchFamily="34" charset="-122"/>
-                <a:cs typeface="Arial" pitchFamily="34" charset="-120"/>
-              </a:rPr>
-              <a:t>أُرسل تصريح العمل للإدارات المعنية للموافقة عليه.</a:t>
-            </a:r>
-            <a:endParaRPr lang="ar-SA" sz="650" dirty="0"/>
-          </a:p>
-        </p:txBody>
-      </p:sp>
-      <p:sp>
-        <p:nvSpPr>
-          <p:cNvPr id="147" name="Shape 145"/>
+        </p:txBody>
+      </p:sp>
+      <p:sp>
+        <p:nvSpPr>
+          <p:cNvPr id="121" name="Shape 119"/>
           <p:cNvSpPr/>
           <p:nvPr/>
         </p:nvSpPr>
@@ -6557,7 +5413,7 @@
       </p:sp>
       <p:sp>
         <p:nvSpPr>
-          <p:cNvPr id="148" name="Shape 146"/>
+          <p:cNvPr id="122" name="Shape 120"/>
           <p:cNvSpPr/>
           <p:nvPr/>
         </p:nvSpPr>
@@ -6589,7 +5445,7 @@
       </p:sp>
       <p:sp>
         <p:nvSpPr>
-          <p:cNvPr id="149" name="Text 147"/>
+          <p:cNvPr id="123" name="Text 121"/>
           <p:cNvSpPr/>
           <p:nvPr/>
         </p:nvSpPr>
@@ -6630,18 +5486,18 @@
       </p:sp>
       <p:sp>
         <p:nvSpPr>
-          <p:cNvPr id="150" name="Shape 148"/>
+          <p:cNvPr id="124" name="Shape 122"/>
           <p:cNvSpPr/>
           <p:nvPr/>
         </p:nvSpPr>
         <p:spPr>
           <a:xfrm>
             <a:off x="1847949" y="4233672"/>
-            <a:ext cx="2017597" cy="914400"/>
+            <a:ext cx="2017597" cy="713232"/>
           </a:xfrm>
           <a:prstGeom prst="roundRect">
             <a:avLst>
-              <a:gd name="adj" fmla="val 8000"/>
+              <a:gd name="adj" fmla="val 10256"/>
             </a:avLst>
           </a:prstGeom>
           <a:solidFill>
@@ -6664,7 +5520,7 @@
       </p:sp>
       <p:sp>
         <p:nvSpPr>
-          <p:cNvPr id="151" name="Shape 149"/>
+          <p:cNvPr id="125" name="Shape 123"/>
           <p:cNvSpPr/>
           <p:nvPr/>
         </p:nvSpPr>
@@ -6689,41 +5545,14 @@
       </p:sp>
       <p:sp>
         <p:nvSpPr>
-          <p:cNvPr id="152" name="Shape 150"/>
-          <p:cNvSpPr/>
-          <p:nvPr/>
-        </p:nvSpPr>
-        <p:spPr>
-          <a:xfrm>
-            <a:off x="1939389" y="4325112"/>
-            <a:ext cx="749808" cy="173736"/>
-          </a:xfrm>
-          <a:prstGeom prst="roundRect">
-            <a:avLst>
-              <a:gd name="adj" fmla="val 50000"/>
-            </a:avLst>
-          </a:prstGeom>
-          <a:solidFill>
-            <a:srgbClr val="2E9E6B"/>
-          </a:solidFill>
-          <a:ln w="12700">
-            <a:solidFill>
-              <a:srgbClr val="2E9E6B"/>
-            </a:solidFill>
-            <a:prstDash val="solid"/>
-          </a:ln>
-        </p:spPr>
-      </p:sp>
-      <p:sp>
-        <p:nvSpPr>
-          <p:cNvPr id="153" name="Text 151"/>
-          <p:cNvSpPr/>
-          <p:nvPr/>
-        </p:nvSpPr>
-        <p:spPr>
-          <a:xfrm>
-            <a:off x="1939389" y="4325112"/>
-            <a:ext cx="749808" cy="173736"/>
+          <p:cNvPr id="126" name="Text 124"/>
+          <p:cNvSpPr/>
+          <p:nvPr/>
+        </p:nvSpPr>
+        <p:spPr>
+          <a:xfrm>
+            <a:off x="1939389" y="4306824"/>
+            <a:ext cx="1834717" cy="210312"/>
           </a:xfrm>
           <a:prstGeom prst="rect">
             <a:avLst/>
@@ -6737,52 +5566,11 @@
           </a:bodyPr>
           <a:lstStyle/>
           <a:p>
-            <a:pPr rtl="1" algn="ctr" indent="0" marL="0">
-              <a:buNone/>
-            </a:pPr>
-            <a:r>
-              <a:rPr lang="ar-SA" altLang="en-US" sz="650" b="1" dirty="0">
-                <a:solidFill>
-                  <a:srgbClr val="FFFFFF"/>
-                </a:solidFill>
-                <a:latin typeface="Arial" pitchFamily="34" charset="0"/>
-                <a:ea typeface="Arial" pitchFamily="34" charset="-122"/>
-                <a:cs typeface="Arial" pitchFamily="34" charset="-120"/>
-              </a:rPr>
-              <a:t>حدث رقم 14</a:t>
-            </a:r>
-            <a:endParaRPr lang="ar-SA" sz="650" dirty="0"/>
-          </a:p>
-        </p:txBody>
-      </p:sp>
-      <p:sp>
-        <p:nvSpPr>
-          <p:cNvPr id="154" name="Text 152"/>
-          <p:cNvSpPr/>
-          <p:nvPr/>
-        </p:nvSpPr>
-        <p:spPr>
-          <a:xfrm>
-            <a:off x="2734917" y="4306824"/>
-            <a:ext cx="1039189" cy="210312"/>
-          </a:xfrm>
-          <a:prstGeom prst="rect">
-            <a:avLst/>
-          </a:prstGeom>
-          <a:noFill/>
-          <a:ln/>
-        </p:spPr>
-        <p:txBody>
-          <a:bodyPr wrap="square" lIns="0" tIns="0" rIns="0" bIns="0" rtlCol="0" anchor="ctr">
-            <a:normAutofit/>
-          </a:bodyPr>
-          <a:lstStyle/>
-          <a:p>
             <a:pPr rtl="1" algn="r" indent="0" marL="0">
               <a:buNone/>
             </a:pPr>
             <a:r>
-              <a:rPr lang="ar-SA" altLang="en-US" sz="900" b="1" dirty="0">
+              <a:rPr lang="ar-SA" altLang="en-US" sz="950" b="1" dirty="0">
                 <a:solidFill>
                   <a:srgbClr val="3D3935"/>
                 </a:solidFill>
@@ -6792,20 +5580,20 @@
               </a:rPr>
               <a:t>خميس 15 أكتوبر 2026</a:t>
             </a:r>
-            <a:endParaRPr lang="ar-SA" sz="900" dirty="0"/>
-          </a:p>
-        </p:txBody>
-      </p:sp>
-      <p:sp>
-        <p:nvSpPr>
-          <p:cNvPr id="155" name="Text 153"/>
+            <a:endParaRPr lang="ar-SA" sz="950" dirty="0"/>
+          </a:p>
+        </p:txBody>
+      </p:sp>
+      <p:sp>
+        <p:nvSpPr>
+          <p:cNvPr id="127" name="Text 125"/>
           <p:cNvSpPr/>
           <p:nvPr/>
         </p:nvSpPr>
         <p:spPr>
           <a:xfrm>
             <a:off x="1939389" y="4553712"/>
-            <a:ext cx="1834717" cy="539496"/>
+            <a:ext cx="1834717" cy="338328"/>
           </a:xfrm>
           <a:prstGeom prst="rect">
             <a:avLst/>
@@ -6858,38 +5646,18 @@
             </a:r>
             <a:endParaRPr lang="ar-SA" sz="650" dirty="0"/>
           </a:p>
-          <a:p>
-            <a:pPr algn="r" indent="0" marL="0">
-              <a:spcAft>
-                <a:spcPts val="100"/>
-              </a:spcAft>
-              <a:buNone/>
-            </a:pPr>
-            <a:r>
-              <a:rPr lang="ar-SA" altLang="en-US" sz="700" dirty="0">
-                <a:solidFill>
-                  <a:srgbClr val="444D55"/>
-                </a:solidFill>
-                <a:latin typeface="Arial" pitchFamily="34" charset="0"/>
-                <a:ea typeface="Arial" pitchFamily="34" charset="-122"/>
-                <a:cs typeface="Arial" pitchFamily="34" charset="-120"/>
-              </a:rPr>
-              <a:t>وردت ملاحظات إضافية من إدارات أخرى.</a:t>
-            </a:r>
-            <a:endParaRPr lang="ar-SA" sz="650" dirty="0"/>
-          </a:p>
-        </p:txBody>
-      </p:sp>
-      <p:sp>
-        <p:nvSpPr>
-          <p:cNvPr id="156" name="Shape 154"/>
-          <p:cNvSpPr/>
-          <p:nvPr/>
-        </p:nvSpPr>
-        <p:spPr>
-          <a:xfrm>
-            <a:off x="2205909" y="2423160"/>
-            <a:ext cx="0" cy="1207008"/>
+        </p:txBody>
+      </p:sp>
+      <p:sp>
+        <p:nvSpPr>
+          <p:cNvPr id="128" name="Shape 126"/>
+          <p:cNvSpPr/>
+          <p:nvPr/>
+        </p:nvSpPr>
+        <p:spPr>
+          <a:xfrm>
+            <a:off x="2205909" y="2624328"/>
+            <a:ext cx="0" cy="1005840"/>
           </a:xfrm>
           <a:prstGeom prst="line">
             <a:avLst/>
@@ -6907,7 +5675,7 @@
       </p:sp>
       <p:sp>
         <p:nvSpPr>
-          <p:cNvPr id="157" name="Shape 155"/>
+          <p:cNvPr id="129" name="Shape 127"/>
           <p:cNvSpPr/>
           <p:nvPr/>
         </p:nvSpPr>
@@ -6939,7 +5707,7 @@
       </p:sp>
       <p:sp>
         <p:nvSpPr>
-          <p:cNvPr id="158" name="Text 156"/>
+          <p:cNvPr id="130" name="Text 128"/>
           <p:cNvSpPr/>
           <p:nvPr/>
         </p:nvSpPr>
@@ -6980,18 +5748,18 @@
       </p:sp>
       <p:sp>
         <p:nvSpPr>
-          <p:cNvPr id="159" name="Shape 157"/>
-          <p:cNvSpPr/>
-          <p:nvPr/>
-        </p:nvSpPr>
-        <p:spPr>
-          <a:xfrm>
-            <a:off x="1197111" y="1508760"/>
-            <a:ext cx="2017597" cy="914400"/>
+          <p:cNvPr id="131" name="Shape 129"/>
+          <p:cNvSpPr/>
+          <p:nvPr/>
+        </p:nvSpPr>
+        <p:spPr>
+          <a:xfrm>
+            <a:off x="1197111" y="1911096"/>
+            <a:ext cx="2017597" cy="713232"/>
           </a:xfrm>
           <a:prstGeom prst="roundRect">
             <a:avLst>
-              <a:gd name="adj" fmla="val 8000"/>
+              <a:gd name="adj" fmla="val 10256"/>
             </a:avLst>
           </a:prstGeom>
           <a:solidFill>
@@ -7014,13 +5782,13 @@
       </p:sp>
       <p:sp>
         <p:nvSpPr>
-          <p:cNvPr id="160" name="Shape 158"/>
-          <p:cNvSpPr/>
-          <p:nvPr/>
-        </p:nvSpPr>
-        <p:spPr>
-          <a:xfrm>
-            <a:off x="1270263" y="1508760"/>
+          <p:cNvPr id="132" name="Shape 130"/>
+          <p:cNvSpPr/>
+          <p:nvPr/>
+        </p:nvSpPr>
+        <p:spPr>
+          <a:xfrm>
+            <a:off x="1270263" y="1911096"/>
             <a:ext cx="1871293" cy="54864"/>
           </a:xfrm>
           <a:prstGeom prst="rect">
@@ -7039,41 +5807,14 @@
       </p:sp>
       <p:sp>
         <p:nvSpPr>
-          <p:cNvPr id="161" name="Shape 159"/>
-          <p:cNvSpPr/>
-          <p:nvPr/>
-        </p:nvSpPr>
-        <p:spPr>
-          <a:xfrm>
-            <a:off x="1288551" y="1600200"/>
-            <a:ext cx="749808" cy="173736"/>
-          </a:xfrm>
-          <a:prstGeom prst="roundRect">
-            <a:avLst>
-              <a:gd name="adj" fmla="val 50000"/>
-            </a:avLst>
-          </a:prstGeom>
-          <a:solidFill>
-            <a:srgbClr val="2E9E6B"/>
-          </a:solidFill>
-          <a:ln w="12700">
-            <a:solidFill>
-              <a:srgbClr val="2E9E6B"/>
-            </a:solidFill>
-            <a:prstDash val="solid"/>
-          </a:ln>
-        </p:spPr>
-      </p:sp>
-      <p:sp>
-        <p:nvSpPr>
-          <p:cNvPr id="162" name="Text 160"/>
-          <p:cNvSpPr/>
-          <p:nvPr/>
-        </p:nvSpPr>
-        <p:spPr>
-          <a:xfrm>
-            <a:off x="1288551" y="1600200"/>
-            <a:ext cx="749808" cy="173736"/>
+          <p:cNvPr id="133" name="Text 131"/>
+          <p:cNvSpPr/>
+          <p:nvPr/>
+        </p:nvSpPr>
+        <p:spPr>
+          <a:xfrm>
+            <a:off x="1288551" y="1984248"/>
+            <a:ext cx="1834717" cy="210312"/>
           </a:xfrm>
           <a:prstGeom prst="rect">
             <a:avLst/>
@@ -7087,52 +5828,11 @@
           </a:bodyPr>
           <a:lstStyle/>
           <a:p>
-            <a:pPr rtl="1" algn="ctr" indent="0" marL="0">
-              <a:buNone/>
-            </a:pPr>
-            <a:r>
-              <a:rPr lang="ar-SA" altLang="en-US" sz="650" b="1" dirty="0">
-                <a:solidFill>
-                  <a:srgbClr val="FFFFFF"/>
-                </a:solidFill>
-                <a:latin typeface="Arial" pitchFamily="34" charset="0"/>
-                <a:ea typeface="Arial" pitchFamily="34" charset="-122"/>
-                <a:cs typeface="Arial" pitchFamily="34" charset="-120"/>
-              </a:rPr>
-              <a:t>حدث رقم 15</a:t>
-            </a:r>
-            <a:endParaRPr lang="ar-SA" sz="650" dirty="0"/>
-          </a:p>
-        </p:txBody>
-      </p:sp>
-      <p:sp>
-        <p:nvSpPr>
-          <p:cNvPr id="163" name="Text 161"/>
-          <p:cNvSpPr/>
-          <p:nvPr/>
-        </p:nvSpPr>
-        <p:spPr>
-          <a:xfrm>
-            <a:off x="2084079" y="1581912"/>
-            <a:ext cx="1039189" cy="210312"/>
-          </a:xfrm>
-          <a:prstGeom prst="rect">
-            <a:avLst/>
-          </a:prstGeom>
-          <a:noFill/>
-          <a:ln/>
-        </p:spPr>
-        <p:txBody>
-          <a:bodyPr wrap="square" lIns="0" tIns="0" rIns="0" bIns="0" rtlCol="0" anchor="ctr">
-            <a:normAutofit/>
-          </a:bodyPr>
-          <a:lstStyle/>
-          <a:p>
             <a:pPr rtl="1" algn="r" indent="0" marL="0">
               <a:buNone/>
             </a:pPr>
             <a:r>
-              <a:rPr lang="ar-SA" altLang="en-US" sz="900" b="1" dirty="0">
+              <a:rPr lang="ar-SA" altLang="en-US" sz="950" b="1" dirty="0">
                 <a:solidFill>
                   <a:srgbClr val="3D3935"/>
                 </a:solidFill>
@@ -7142,20 +5842,20 @@
               </a:rPr>
               <a:t>اثنين 19 أكتوبر 2026</a:t>
             </a:r>
-            <a:endParaRPr lang="ar-SA" sz="900" dirty="0"/>
-          </a:p>
-        </p:txBody>
-      </p:sp>
-      <p:sp>
-        <p:nvSpPr>
-          <p:cNvPr id="164" name="Text 162"/>
-          <p:cNvSpPr/>
-          <p:nvPr/>
-        </p:nvSpPr>
-        <p:spPr>
-          <a:xfrm>
-            <a:off x="1288551" y="1828800"/>
-            <a:ext cx="1834717" cy="539496"/>
+            <a:endParaRPr lang="ar-SA" sz="950" dirty="0"/>
+          </a:p>
+        </p:txBody>
+      </p:sp>
+      <p:sp>
+        <p:nvSpPr>
+          <p:cNvPr id="134" name="Text 132"/>
+          <p:cNvSpPr/>
+          <p:nvPr/>
+        </p:nvSpPr>
+        <p:spPr>
+          <a:xfrm>
+            <a:off x="1288551" y="2231136"/>
+            <a:ext cx="1834717" cy="338328"/>
           </a:xfrm>
           <a:prstGeom prst="rect">
             <a:avLst/>
@@ -7208,38 +5908,18 @@
             </a:r>
             <a:endParaRPr lang="ar-SA" sz="650" dirty="0"/>
           </a:p>
-          <a:p>
-            <a:pPr algn="r" indent="0" marL="0">
-              <a:spcAft>
-                <a:spcPts val="100"/>
-              </a:spcAft>
-              <a:buNone/>
-            </a:pPr>
-            <a:r>
-              <a:rPr lang="ar-SA" altLang="en-US" sz="700" dirty="0">
-                <a:solidFill>
-                  <a:srgbClr val="444D55"/>
-                </a:solidFill>
-                <a:latin typeface="Arial" pitchFamily="34" charset="0"/>
-                <a:ea typeface="Arial" pitchFamily="34" charset="-122"/>
-                <a:cs typeface="Arial" pitchFamily="34" charset="-120"/>
-              </a:rPr>
-              <a:t>قُدّمت المراجعة الثالثة للبيان للجميع للاعتماد.</a:t>
-            </a:r>
-            <a:endParaRPr lang="ar-SA" sz="650" dirty="0"/>
-          </a:p>
-        </p:txBody>
-      </p:sp>
-      <p:sp>
-        <p:nvSpPr>
-          <p:cNvPr id="165" name="Shape 163"/>
+        </p:txBody>
+      </p:sp>
+      <p:sp>
+        <p:nvSpPr>
+          <p:cNvPr id="135" name="Shape 133"/>
           <p:cNvSpPr/>
           <p:nvPr/>
         </p:nvSpPr>
         <p:spPr>
           <a:xfrm>
             <a:off x="1555072" y="4050792"/>
-            <a:ext cx="0" cy="1207008"/>
+            <a:ext cx="0" cy="1005840"/>
           </a:xfrm>
           <a:prstGeom prst="line">
             <a:avLst/>
@@ -7257,7 +5937,7 @@
       </p:sp>
       <p:sp>
         <p:nvSpPr>
-          <p:cNvPr id="166" name="Shape 164"/>
+          <p:cNvPr id="136" name="Shape 134"/>
           <p:cNvSpPr/>
           <p:nvPr/>
         </p:nvSpPr>
@@ -7289,7 +5969,7 @@
       </p:sp>
       <p:sp>
         <p:nvSpPr>
-          <p:cNvPr id="167" name="Text 165"/>
+          <p:cNvPr id="137" name="Text 135"/>
           <p:cNvSpPr/>
           <p:nvPr/>
         </p:nvSpPr>
@@ -7330,18 +6010,18 @@
       </p:sp>
       <p:sp>
         <p:nvSpPr>
-          <p:cNvPr id="168" name="Shape 166"/>
-          <p:cNvSpPr/>
-          <p:nvPr/>
-        </p:nvSpPr>
-        <p:spPr>
-          <a:xfrm>
-            <a:off x="546273" y="5257800"/>
-            <a:ext cx="2017597" cy="914400"/>
+          <p:cNvPr id="138" name="Shape 136"/>
+          <p:cNvSpPr/>
+          <p:nvPr/>
+        </p:nvSpPr>
+        <p:spPr>
+          <a:xfrm>
+            <a:off x="546273" y="5056632"/>
+            <a:ext cx="2017597" cy="713232"/>
           </a:xfrm>
           <a:prstGeom prst="roundRect">
             <a:avLst>
-              <a:gd name="adj" fmla="val 8000"/>
+              <a:gd name="adj" fmla="val 10256"/>
             </a:avLst>
           </a:prstGeom>
           <a:solidFill>
@@ -7364,13 +6044,13 @@
       </p:sp>
       <p:sp>
         <p:nvSpPr>
-          <p:cNvPr id="169" name="Shape 167"/>
-          <p:cNvSpPr/>
-          <p:nvPr/>
-        </p:nvSpPr>
-        <p:spPr>
-          <a:xfrm>
-            <a:off x="619425" y="5257800"/>
+          <p:cNvPr id="139" name="Shape 137"/>
+          <p:cNvSpPr/>
+          <p:nvPr/>
+        </p:nvSpPr>
+        <p:spPr>
+          <a:xfrm>
+            <a:off x="619425" y="5056632"/>
             <a:ext cx="1871293" cy="54864"/>
           </a:xfrm>
           <a:prstGeom prst="rect">
@@ -7389,41 +6069,14 @@
       </p:sp>
       <p:sp>
         <p:nvSpPr>
-          <p:cNvPr id="170" name="Shape 168"/>
-          <p:cNvSpPr/>
-          <p:nvPr/>
-        </p:nvSpPr>
-        <p:spPr>
-          <a:xfrm>
-            <a:off x="637713" y="5349240"/>
-            <a:ext cx="749808" cy="173736"/>
-          </a:xfrm>
-          <a:prstGeom prst="roundRect">
-            <a:avLst>
-              <a:gd name="adj" fmla="val 50000"/>
-            </a:avLst>
-          </a:prstGeom>
-          <a:solidFill>
-            <a:srgbClr val="2E9E6B"/>
-          </a:solidFill>
-          <a:ln w="12700">
-            <a:solidFill>
-              <a:srgbClr val="2E9E6B"/>
-            </a:solidFill>
-            <a:prstDash val="solid"/>
-          </a:ln>
-        </p:spPr>
-      </p:sp>
-      <p:sp>
-        <p:nvSpPr>
-          <p:cNvPr id="171" name="Text 169"/>
-          <p:cNvSpPr/>
-          <p:nvPr/>
-        </p:nvSpPr>
-        <p:spPr>
-          <a:xfrm>
-            <a:off x="637713" y="5349240"/>
-            <a:ext cx="749808" cy="173736"/>
+          <p:cNvPr id="140" name="Text 138"/>
+          <p:cNvSpPr/>
+          <p:nvPr/>
+        </p:nvSpPr>
+        <p:spPr>
+          <a:xfrm>
+            <a:off x="637713" y="5129784"/>
+            <a:ext cx="1834717" cy="210312"/>
           </a:xfrm>
           <a:prstGeom prst="rect">
             <a:avLst/>
@@ -7437,52 +6090,11 @@
           </a:bodyPr>
           <a:lstStyle/>
           <a:p>
-            <a:pPr rtl="1" algn="ctr" indent="0" marL="0">
-              <a:buNone/>
-            </a:pPr>
-            <a:r>
-              <a:rPr lang="ar-SA" altLang="en-US" sz="650" b="1" dirty="0">
-                <a:solidFill>
-                  <a:srgbClr val="FFFFFF"/>
-                </a:solidFill>
-                <a:latin typeface="Arial" pitchFamily="34" charset="0"/>
-                <a:ea typeface="Arial" pitchFamily="34" charset="-122"/>
-                <a:cs typeface="Arial" pitchFamily="34" charset="-120"/>
-              </a:rPr>
-              <a:t>حدث رقم 16</a:t>
-            </a:r>
-            <a:endParaRPr lang="ar-SA" sz="650" dirty="0"/>
-          </a:p>
-        </p:txBody>
-      </p:sp>
-      <p:sp>
-        <p:nvSpPr>
-          <p:cNvPr id="172" name="Text 170"/>
-          <p:cNvSpPr/>
-          <p:nvPr/>
-        </p:nvSpPr>
-        <p:spPr>
-          <a:xfrm>
-            <a:off x="1433241" y="5330952"/>
-            <a:ext cx="1039189" cy="210312"/>
-          </a:xfrm>
-          <a:prstGeom prst="rect">
-            <a:avLst/>
-          </a:prstGeom>
-          <a:noFill/>
-          <a:ln/>
-        </p:spPr>
-        <p:txBody>
-          <a:bodyPr wrap="square" lIns="0" tIns="0" rIns="0" bIns="0" rtlCol="0" anchor="ctr">
-            <a:normAutofit/>
-          </a:bodyPr>
-          <a:lstStyle/>
-          <a:p>
             <a:pPr rtl="1" algn="r" indent="0" marL="0">
               <a:buNone/>
             </a:pPr>
             <a:r>
-              <a:rPr lang="ar-SA" altLang="en-US" sz="900" b="1" dirty="0">
+              <a:rPr lang="ar-SA" altLang="en-US" sz="950" b="1" dirty="0">
                 <a:solidFill>
                   <a:srgbClr val="3D3935"/>
                 </a:solidFill>
@@ -7492,20 +6104,20 @@
               </a:rPr>
               <a:t>ثلاثاء 20 أكتوبر 2026</a:t>
             </a:r>
-            <a:endParaRPr lang="ar-SA" sz="900" dirty="0"/>
-          </a:p>
-        </p:txBody>
-      </p:sp>
-      <p:sp>
-        <p:nvSpPr>
-          <p:cNvPr id="173" name="Text 171"/>
-          <p:cNvSpPr/>
-          <p:nvPr/>
-        </p:nvSpPr>
-        <p:spPr>
-          <a:xfrm>
-            <a:off x="637713" y="5577840"/>
-            <a:ext cx="1834717" cy="539496"/>
+            <a:endParaRPr lang="ar-SA" sz="950" dirty="0"/>
+          </a:p>
+        </p:txBody>
+      </p:sp>
+      <p:sp>
+        <p:nvSpPr>
+          <p:cNvPr id="141" name="Text 139"/>
+          <p:cNvSpPr/>
+          <p:nvPr/>
+        </p:nvSpPr>
+        <p:spPr>
+          <a:xfrm>
+            <a:off x="637713" y="5376672"/>
+            <a:ext cx="1834717" cy="338328"/>
           </a:xfrm>
           <a:prstGeom prst="rect">
             <a:avLst/>
@@ -7558,31 +6170,11 @@
             </a:r>
             <a:endParaRPr lang="ar-SA" sz="650" dirty="0"/>
           </a:p>
-          <a:p>
-            <a:pPr algn="r" indent="0" marL="0">
-              <a:spcAft>
-                <a:spcPts val="100"/>
-              </a:spcAft>
-              <a:buNone/>
-            </a:pPr>
-            <a:r>
-              <a:rPr lang="ar-SA" altLang="en-US" sz="700" dirty="0">
-                <a:solidFill>
-                  <a:srgbClr val="444D55"/>
-                </a:solidFill>
-                <a:latin typeface="Arial" pitchFamily="34" charset="0"/>
-                <a:ea typeface="Arial" pitchFamily="34" charset="-122"/>
-                <a:cs typeface="Arial" pitchFamily="34" charset="-120"/>
-              </a:rPr>
-              <a:t>تم إغلاق الاستفسار المتبقي بشأن بيان طريقة العمل.</a:t>
-            </a:r>
-            <a:endParaRPr lang="ar-SA" sz="650" dirty="0"/>
-          </a:p>
-        </p:txBody>
-      </p:sp>
-      <p:sp>
-        <p:nvSpPr>
-          <p:cNvPr id="174" name="Shape 172"/>
+        </p:txBody>
+      </p:sp>
+      <p:sp>
+        <p:nvSpPr>
+          <p:cNvPr id="142" name="Shape 140"/>
           <p:cNvSpPr/>
           <p:nvPr/>
         </p:nvSpPr>
@@ -7607,7 +6199,7 @@
       </p:sp>
       <p:sp>
         <p:nvSpPr>
-          <p:cNvPr id="175" name="Shape 173"/>
+          <p:cNvPr id="143" name="Shape 141"/>
           <p:cNvSpPr/>
           <p:nvPr/>
         </p:nvSpPr>
@@ -7639,7 +6231,7 @@
       </p:sp>
       <p:sp>
         <p:nvSpPr>
-          <p:cNvPr id="176" name="Text 174"/>
+          <p:cNvPr id="144" name="Text 142"/>
           <p:cNvSpPr/>
           <p:nvPr/>
         </p:nvSpPr>
@@ -7680,18 +6272,18 @@
       </p:sp>
       <p:sp>
         <p:nvSpPr>
-          <p:cNvPr id="177" name="Shape 175"/>
-          <p:cNvSpPr/>
-          <p:nvPr/>
-        </p:nvSpPr>
-        <p:spPr>
-          <a:xfrm>
-            <a:off x="274320" y="2532888"/>
-            <a:ext cx="2017597" cy="914400"/>
+          <p:cNvPr id="145" name="Shape 143"/>
+          <p:cNvSpPr/>
+          <p:nvPr/>
+        </p:nvSpPr>
+        <p:spPr>
+          <a:xfrm>
+            <a:off x="274320" y="2734056"/>
+            <a:ext cx="2017597" cy="713232"/>
           </a:xfrm>
           <a:prstGeom prst="roundRect">
             <a:avLst>
-              <a:gd name="adj" fmla="val 8000"/>
+              <a:gd name="adj" fmla="val 10256"/>
             </a:avLst>
           </a:prstGeom>
           <a:solidFill>
@@ -7714,13 +6306,13 @@
       </p:sp>
       <p:sp>
         <p:nvSpPr>
-          <p:cNvPr id="178" name="Shape 176"/>
-          <p:cNvSpPr/>
-          <p:nvPr/>
-        </p:nvSpPr>
-        <p:spPr>
-          <a:xfrm>
-            <a:off x="347472" y="2532888"/>
+          <p:cNvPr id="146" name="Shape 144"/>
+          <p:cNvSpPr/>
+          <p:nvPr/>
+        </p:nvSpPr>
+        <p:spPr>
+          <a:xfrm>
+            <a:off x="347472" y="2734056"/>
             <a:ext cx="1871293" cy="54864"/>
           </a:xfrm>
           <a:prstGeom prst="rect">
@@ -7739,41 +6331,14 @@
       </p:sp>
       <p:sp>
         <p:nvSpPr>
-          <p:cNvPr id="179" name="Shape 177"/>
-          <p:cNvSpPr/>
-          <p:nvPr/>
-        </p:nvSpPr>
-        <p:spPr>
-          <a:xfrm>
-            <a:off x="365760" y="2624328"/>
-            <a:ext cx="749808" cy="173736"/>
-          </a:xfrm>
-          <a:prstGeom prst="roundRect">
-            <a:avLst>
-              <a:gd name="adj" fmla="val 50000"/>
-            </a:avLst>
-          </a:prstGeom>
-          <a:solidFill>
-            <a:srgbClr val="2E9E6B"/>
-          </a:solidFill>
-          <a:ln w="12700">
-            <a:solidFill>
-              <a:srgbClr val="2E9E6B"/>
-            </a:solidFill>
-            <a:prstDash val="solid"/>
-          </a:ln>
-        </p:spPr>
-      </p:sp>
-      <p:sp>
-        <p:nvSpPr>
-          <p:cNvPr id="180" name="Text 178"/>
-          <p:cNvSpPr/>
-          <p:nvPr/>
-        </p:nvSpPr>
-        <p:spPr>
-          <a:xfrm>
-            <a:off x="365760" y="2624328"/>
-            <a:ext cx="749808" cy="173736"/>
+          <p:cNvPr id="147" name="Text 145"/>
+          <p:cNvSpPr/>
+          <p:nvPr/>
+        </p:nvSpPr>
+        <p:spPr>
+          <a:xfrm>
+            <a:off x="365760" y="2807208"/>
+            <a:ext cx="1834717" cy="210312"/>
           </a:xfrm>
           <a:prstGeom prst="rect">
             <a:avLst/>
@@ -7787,52 +6352,11 @@
           </a:bodyPr>
           <a:lstStyle/>
           <a:p>
-            <a:pPr rtl="1" algn="ctr" indent="0" marL="0">
-              <a:buNone/>
-            </a:pPr>
-            <a:r>
-              <a:rPr lang="ar-SA" altLang="en-US" sz="650" b="1" dirty="0">
-                <a:solidFill>
-                  <a:srgbClr val="FFFFFF"/>
-                </a:solidFill>
-                <a:latin typeface="Arial" pitchFamily="34" charset="0"/>
-                <a:ea typeface="Arial" pitchFamily="34" charset="-122"/>
-                <a:cs typeface="Arial" pitchFamily="34" charset="-120"/>
-              </a:rPr>
-              <a:t>حدث رقم 17</a:t>
-            </a:r>
-            <a:endParaRPr lang="ar-SA" sz="650" dirty="0"/>
-          </a:p>
-        </p:txBody>
-      </p:sp>
-      <p:sp>
-        <p:nvSpPr>
-          <p:cNvPr id="181" name="Text 179"/>
-          <p:cNvSpPr/>
-          <p:nvPr/>
-        </p:nvSpPr>
-        <p:spPr>
-          <a:xfrm>
-            <a:off x="1161288" y="2606040"/>
-            <a:ext cx="1039189" cy="210312"/>
-          </a:xfrm>
-          <a:prstGeom prst="rect">
-            <a:avLst/>
-          </a:prstGeom>
-          <a:noFill/>
-          <a:ln/>
-        </p:spPr>
-        <p:txBody>
-          <a:bodyPr wrap="square" lIns="0" tIns="0" rIns="0" bIns="0" rtlCol="0" anchor="ctr">
-            <a:normAutofit/>
-          </a:bodyPr>
-          <a:lstStyle/>
-          <a:p>
             <a:pPr rtl="1" algn="r" indent="0" marL="0">
               <a:buNone/>
             </a:pPr>
             <a:r>
-              <a:rPr lang="ar-SA" altLang="en-US" sz="900" b="1" dirty="0">
+              <a:rPr lang="ar-SA" altLang="en-US" sz="950" b="1" dirty="0">
                 <a:solidFill>
                   <a:srgbClr val="3D3935"/>
                 </a:solidFill>
@@ -7842,20 +6366,20 @@
               </a:rPr>
               <a:t>أربعاء 21 أكتوبر 2026</a:t>
             </a:r>
-            <a:endParaRPr lang="ar-SA" sz="900" dirty="0"/>
-          </a:p>
-        </p:txBody>
-      </p:sp>
-      <p:sp>
-        <p:nvSpPr>
-          <p:cNvPr id="182" name="Text 180"/>
-          <p:cNvSpPr/>
-          <p:nvPr/>
-        </p:nvSpPr>
-        <p:spPr>
-          <a:xfrm>
-            <a:off x="365760" y="2852928"/>
-            <a:ext cx="1834717" cy="539496"/>
+            <a:endParaRPr lang="ar-SA" sz="950" dirty="0"/>
+          </a:p>
+        </p:txBody>
+      </p:sp>
+      <p:sp>
+        <p:nvSpPr>
+          <p:cNvPr id="148" name="Text 146"/>
+          <p:cNvSpPr/>
+          <p:nvPr/>
+        </p:nvSpPr>
+        <p:spPr>
+          <a:xfrm>
+            <a:off x="365760" y="3054096"/>
+            <a:ext cx="1834717" cy="338328"/>
           </a:xfrm>
           <a:prstGeom prst="rect">
             <a:avLst/>
@@ -7905,26 +6429,6 @@
                 <a:cs typeface="Arial" pitchFamily="34" charset="-120"/>
               </a:rPr>
               <a:t>تصريح العمل جاهز للتوقيع</a:t>
-            </a:r>
-            <a:endParaRPr lang="ar-SA" sz="650" dirty="0"/>
-          </a:p>
-          <a:p>
-            <a:pPr algn="r" indent="0" marL="0">
-              <a:spcAft>
-                <a:spcPts val="100"/>
-              </a:spcAft>
-              <a:buNone/>
-            </a:pPr>
-            <a:r>
-              <a:rPr lang="ar-SA" altLang="en-US" sz="700" dirty="0">
-                <a:solidFill>
-                  <a:srgbClr val="444D55"/>
-                </a:solidFill>
-                <a:latin typeface="Arial" pitchFamily="34" charset="0"/>
-                <a:ea typeface="Arial" pitchFamily="34" charset="-122"/>
-                <a:cs typeface="Arial" pitchFamily="34" charset="-120"/>
-              </a:rPr>
-              <a:t>أصبح تصريح العمل جاهزاً للتوقيع والإصدار.</a:t>
             </a:r>
             <a:endParaRPr lang="ar-SA" sz="650" dirty="0"/>
           </a:p>

</xml_diff>